<commit_message>
renamed paper pdf for clarity, added outline to presentation
</commit_message>
<xml_diff>
--- a/presentation/miniproject_presentation.pptx
+++ b/presentation/miniproject_presentation.pptx
@@ -7,6 +7,9 @@
   <p:sldIdLst>
     <p:sldId id="256" r:id="rId2"/>
     <p:sldId id="257" r:id="rId3"/>
+    <p:sldId id="258" r:id="rId4"/>
+    <p:sldId id="259" r:id="rId5"/>
+    <p:sldId id="260" r:id="rId6"/>
   </p:sldIdLst>
   <p:sldSz cx="12192000" cy="6858000"/>
   <p:notesSz cx="6858000" cy="9144000"/>
@@ -105,7 +108,126 @@
       </a:defRPr>
     </a:lvl9pPr>
   </p:defaultTextStyle>
+  <p:extLst>
+    <p:ext uri="{EFAFB233-063F-42B5-8137-9DF3F51BA10A}">
+      <p15:sldGuideLst xmlns:p15="http://schemas.microsoft.com/office/powerpoint/2012/main"/>
+    </p:ext>
+  </p:extLst>
 </p:presentation>
+</file>
+
+<file path=ppt/revisionInfo.xml><?xml version="1.0" encoding="utf-8"?>
+<p1510:revInfo xmlns:a="http://schemas.openxmlformats.org/drawingml/2006/main" xmlns:r="http://schemas.openxmlformats.org/officeDocument/2006/relationships" xmlns:p1510="http://schemas.microsoft.com/office/powerpoint/2015/10/main">
+  <p1510:revLst>
+    <p1510:client id="{B81A0D32-7048-4EBC-999B-B8680BBC1F6E}" v="2" dt="2026-04-29T14:13:22.444"/>
+  </p1510:revLst>
+</p1510:revInfo>
+</file>
+
+<file path=ppt/changesInfos/changesInfo1.xml><?xml version="1.0" encoding="utf-8"?>
+<pc:chgInfo xmlns:a="http://schemas.openxmlformats.org/drawingml/2006/main" xmlns:r="http://schemas.openxmlformats.org/officeDocument/2006/relationships" xmlns:ac="http://schemas.microsoft.com/office/drawing/2013/main/command" xmlns:pc="http://schemas.microsoft.com/office/powerpoint/2013/main/command">
+  <pc:docChgLst>
+    <pc:chgData name="tpayer27@gmail.com" userId="7e90483bd88d641e" providerId="LiveId" clId="{33B4280C-14B8-46FE-96E8-14997B42EB38}"/>
+    <pc:docChg chg="undo custSel addSld modSld">
+      <pc:chgData name="tpayer27@gmail.com" userId="7e90483bd88d641e" providerId="LiveId" clId="{33B4280C-14B8-46FE-96E8-14997B42EB38}" dt="2026-04-29T14:20:18.640" v="700" actId="1076"/>
+      <pc:docMkLst>
+        <pc:docMk/>
+      </pc:docMkLst>
+      <pc:sldChg chg="modSp mod">
+        <pc:chgData name="tpayer27@gmail.com" userId="7e90483bd88d641e" providerId="LiveId" clId="{33B4280C-14B8-46FE-96E8-14997B42EB38}" dt="2026-04-29T14:18:23.395" v="511" actId="5793"/>
+        <pc:sldMkLst>
+          <pc:docMk/>
+          <pc:sldMk cId="568311737" sldId="257"/>
+        </pc:sldMkLst>
+        <pc:spChg chg="mod">
+          <ac:chgData name="tpayer27@gmail.com" userId="7e90483bd88d641e" providerId="LiveId" clId="{33B4280C-14B8-46FE-96E8-14997B42EB38}" dt="2026-04-29T14:11:02.161" v="10" actId="20577"/>
+          <ac:spMkLst>
+            <pc:docMk/>
+            <pc:sldMk cId="568311737" sldId="257"/>
+            <ac:spMk id="2" creationId="{3FE5773C-1F66-11D1-5497-5C7C5A6C79CE}"/>
+          </ac:spMkLst>
+        </pc:spChg>
+        <pc:spChg chg="mod">
+          <ac:chgData name="tpayer27@gmail.com" userId="7e90483bd88d641e" providerId="LiveId" clId="{33B4280C-14B8-46FE-96E8-14997B42EB38}" dt="2026-04-29T14:18:23.395" v="511" actId="5793"/>
+          <ac:spMkLst>
+            <pc:docMk/>
+            <pc:sldMk cId="568311737" sldId="257"/>
+            <ac:spMk id="3" creationId="{B2EC310B-29A8-B70B-69DE-B8313BD22904}"/>
+          </ac:spMkLst>
+        </pc:spChg>
+      </pc:sldChg>
+      <pc:sldChg chg="modSp new mod">
+        <pc:chgData name="tpayer27@gmail.com" userId="7e90483bd88d641e" providerId="LiveId" clId="{33B4280C-14B8-46FE-96E8-14997B42EB38}" dt="2026-04-29T14:18:34.595" v="551" actId="20577"/>
+        <pc:sldMkLst>
+          <pc:docMk/>
+          <pc:sldMk cId="401316806" sldId="258"/>
+        </pc:sldMkLst>
+        <pc:spChg chg="mod">
+          <ac:chgData name="tpayer27@gmail.com" userId="7e90483bd88d641e" providerId="LiveId" clId="{33B4280C-14B8-46FE-96E8-14997B42EB38}" dt="2026-04-29T14:18:34.595" v="551" actId="20577"/>
+          <ac:spMkLst>
+            <pc:docMk/>
+            <pc:sldMk cId="401316806" sldId="258"/>
+            <ac:spMk id="2" creationId="{A8ED7CDF-D330-A82F-973B-4B6B36C09665}"/>
+          </ac:spMkLst>
+        </pc:spChg>
+      </pc:sldChg>
+      <pc:sldChg chg="modSp new mod">
+        <pc:chgData name="tpayer27@gmail.com" userId="7e90483bd88d641e" providerId="LiveId" clId="{33B4280C-14B8-46FE-96E8-14997B42EB38}" dt="2026-04-29T14:19:16.347" v="621" actId="5793"/>
+        <pc:sldMkLst>
+          <pc:docMk/>
+          <pc:sldMk cId="1546665739" sldId="259"/>
+        </pc:sldMkLst>
+        <pc:spChg chg="mod">
+          <ac:chgData name="tpayer27@gmail.com" userId="7e90483bd88d641e" providerId="LiveId" clId="{33B4280C-14B8-46FE-96E8-14997B42EB38}" dt="2026-04-29T14:18:56" v="602" actId="20577"/>
+          <ac:spMkLst>
+            <pc:docMk/>
+            <pc:sldMk cId="1546665739" sldId="259"/>
+            <ac:spMk id="2" creationId="{9B2EDE5B-FF14-7646-7A1F-49B8E3A50699}"/>
+          </ac:spMkLst>
+        </pc:spChg>
+        <pc:spChg chg="mod">
+          <ac:chgData name="tpayer27@gmail.com" userId="7e90483bd88d641e" providerId="LiveId" clId="{33B4280C-14B8-46FE-96E8-14997B42EB38}" dt="2026-04-29T14:19:16.347" v="621" actId="5793"/>
+          <ac:spMkLst>
+            <pc:docMk/>
+            <pc:sldMk cId="1546665739" sldId="259"/>
+            <ac:spMk id="3" creationId="{E02D3514-E1F8-A44C-72EC-82AA96464F45}"/>
+          </ac:spMkLst>
+        </pc:spChg>
+      </pc:sldChg>
+      <pc:sldChg chg="addSp delSp modSp new mod">
+        <pc:chgData name="tpayer27@gmail.com" userId="7e90483bd88d641e" providerId="LiveId" clId="{33B4280C-14B8-46FE-96E8-14997B42EB38}" dt="2026-04-29T14:20:18.640" v="700" actId="1076"/>
+        <pc:sldMkLst>
+          <pc:docMk/>
+          <pc:sldMk cId="2573603863" sldId="260"/>
+        </pc:sldMkLst>
+        <pc:spChg chg="mod">
+          <ac:chgData name="tpayer27@gmail.com" userId="7e90483bd88d641e" providerId="LiveId" clId="{33B4280C-14B8-46FE-96E8-14997B42EB38}" dt="2026-04-29T14:19:47.309" v="698" actId="20577"/>
+          <ac:spMkLst>
+            <pc:docMk/>
+            <pc:sldMk cId="2573603863" sldId="260"/>
+            <ac:spMk id="2" creationId="{59807686-857B-4667-FD35-484CD1486A6C}"/>
+          </ac:spMkLst>
+        </pc:spChg>
+        <pc:spChg chg="del">
+          <ac:chgData name="tpayer27@gmail.com" userId="7e90483bd88d641e" providerId="LiveId" clId="{33B4280C-14B8-46FE-96E8-14997B42EB38}" dt="2026-04-29T14:20:15.035" v="699" actId="22"/>
+          <ac:spMkLst>
+            <pc:docMk/>
+            <pc:sldMk cId="2573603863" sldId="260"/>
+            <ac:spMk id="3" creationId="{4ED97D5A-69CA-43A5-F539-61D03C119579}"/>
+          </ac:spMkLst>
+        </pc:spChg>
+        <pc:picChg chg="add mod ord">
+          <ac:chgData name="tpayer27@gmail.com" userId="7e90483bd88d641e" providerId="LiveId" clId="{33B4280C-14B8-46FE-96E8-14997B42EB38}" dt="2026-04-29T14:20:18.640" v="700" actId="1076"/>
+          <ac:picMkLst>
+            <pc:docMk/>
+            <pc:sldMk cId="2573603863" sldId="260"/>
+            <ac:picMk id="5" creationId="{26648917-2D3F-6DC0-C0A5-CEA1CCDF4979}"/>
+          </ac:picMkLst>
+        </pc:picChg>
+      </pc:sldChg>
+    </pc:docChg>
+  </pc:docChgLst>
+</pc:chgInfo>
 </file>
 
 <file path=ppt/slideLayouts/slideLayout1.xml><?xml version="1.0" encoding="utf-8"?>
@@ -3504,6 +3626,10 @@
           <a:bodyPr/>
           <a:lstStyle/>
           <a:p>
+            <a:r>
+              <a:rPr lang="de-CH" dirty="0"/>
+              <a:t>Outline</a:t>
+            </a:r>
             <a:endParaRPr lang="en-CH" dirty="0"/>
           </a:p>
         </p:txBody>
@@ -3531,6 +3657,33 @@
           </a:bodyPr>
           <a:lstStyle/>
           <a:p>
+            <a:r>
+              <a:rPr lang="en-US" dirty="0"/>
+              <a:t>Introduction to Study &amp; Design</a:t>
+            </a:r>
+          </a:p>
+          <a:p>
+            <a:r>
+              <a:rPr lang="en-US" dirty="0"/>
+              <a:t>Transparency and Reproducibility</a:t>
+            </a:r>
+          </a:p>
+          <a:p>
+            <a:r>
+              <a:rPr lang="en-US" dirty="0"/>
+              <a:t>Soundness of Analyses</a:t>
+            </a:r>
+          </a:p>
+          <a:p>
+            <a:r>
+              <a:rPr lang="en-US" dirty="0"/>
+              <a:t>Principles of GRP</a:t>
+            </a:r>
+          </a:p>
+          <a:p>
+            <a:pPr marL="0" indent="0">
+              <a:buNone/>
+            </a:pPr>
             <a:endParaRPr lang="en-US" dirty="0"/>
           </a:p>
         </p:txBody>
@@ -3539,6 +3692,302 @@
     <p:extLst>
       <p:ext uri="{BB962C8B-B14F-4D97-AF65-F5344CB8AC3E}">
         <p14:creationId xmlns:p14="http://schemas.microsoft.com/office/powerpoint/2010/main" val="568311737"/>
+      </p:ext>
+    </p:extLst>
+  </p:cSld>
+  <p:clrMapOvr>
+    <a:masterClrMapping/>
+  </p:clrMapOvr>
+</p:sld>
+</file>
+
+<file path=ppt/slides/slide3.xml><?xml version="1.0" encoding="utf-8"?>
+<p:sld xmlns:a="http://schemas.openxmlformats.org/drawingml/2006/main" xmlns:r="http://schemas.openxmlformats.org/officeDocument/2006/relationships" xmlns:p="http://schemas.openxmlformats.org/presentationml/2006/main">
+  <p:cSld>
+    <p:spTree>
+      <p:nvGrpSpPr>
+        <p:cNvPr id="1" name=""/>
+        <p:cNvGrpSpPr/>
+        <p:nvPr/>
+      </p:nvGrpSpPr>
+      <p:grpSpPr>
+        <a:xfrm>
+          <a:off x="0" y="0"/>
+          <a:ext cx="0" cy="0"/>
+          <a:chOff x="0" y="0"/>
+          <a:chExt cx="0" cy="0"/>
+        </a:xfrm>
+      </p:grpSpPr>
+      <p:sp>
+        <p:nvSpPr>
+          <p:cNvPr id="2" name="Title 1">
+            <a:extLst>
+              <a:ext uri="{FF2B5EF4-FFF2-40B4-BE49-F238E27FC236}">
+                <a16:creationId xmlns:a16="http://schemas.microsoft.com/office/drawing/2014/main" id="{A8ED7CDF-D330-A82F-973B-4B6B36C09665}"/>
+              </a:ext>
+            </a:extLst>
+          </p:cNvPr>
+          <p:cNvSpPr>
+            <a:spLocks noGrp="1"/>
+          </p:cNvSpPr>
+          <p:nvPr>
+            <p:ph type="title"/>
+          </p:nvPr>
+        </p:nvSpPr>
+        <p:spPr/>
+        <p:txBody>
+          <a:bodyPr/>
+          <a:lstStyle/>
+          <a:p>
+            <a:r>
+              <a:rPr lang="de-CH" dirty="0" err="1"/>
+              <a:t>Introduction</a:t>
+            </a:r>
+            <a:r>
+              <a:rPr lang="de-CH" dirty="0"/>
+              <a:t> </a:t>
+            </a:r>
+            <a:r>
+              <a:rPr lang="de-CH" dirty="0" err="1"/>
+              <a:t>into</a:t>
+            </a:r>
+            <a:r>
+              <a:rPr lang="de-CH" dirty="0"/>
+              <a:t> </a:t>
+            </a:r>
+            <a:r>
+              <a:rPr lang="de-CH" dirty="0" err="1"/>
+              <a:t>study</a:t>
+            </a:r>
+            <a:endParaRPr lang="en-CH" dirty="0"/>
+          </a:p>
+        </p:txBody>
+      </p:sp>
+      <p:sp>
+        <p:nvSpPr>
+          <p:cNvPr id="3" name="Content Placeholder 2">
+            <a:extLst>
+              <a:ext uri="{FF2B5EF4-FFF2-40B4-BE49-F238E27FC236}">
+                <a16:creationId xmlns:a16="http://schemas.microsoft.com/office/drawing/2014/main" id="{5CF9183D-445C-25C4-6291-EDF4CDACBE96}"/>
+              </a:ext>
+            </a:extLst>
+          </p:cNvPr>
+          <p:cNvSpPr>
+            <a:spLocks noGrp="1"/>
+          </p:cNvSpPr>
+          <p:nvPr>
+            <p:ph idx="1"/>
+          </p:nvPr>
+        </p:nvSpPr>
+        <p:spPr/>
+        <p:txBody>
+          <a:bodyPr/>
+          <a:lstStyle/>
+          <a:p>
+            <a:endParaRPr lang="en-CH"/>
+          </a:p>
+        </p:txBody>
+      </p:sp>
+    </p:spTree>
+    <p:extLst>
+      <p:ext uri="{BB962C8B-B14F-4D97-AF65-F5344CB8AC3E}">
+        <p14:creationId xmlns:p14="http://schemas.microsoft.com/office/powerpoint/2010/main" val="401316806"/>
+      </p:ext>
+    </p:extLst>
+  </p:cSld>
+  <p:clrMapOvr>
+    <a:masterClrMapping/>
+  </p:clrMapOvr>
+</p:sld>
+</file>
+
+<file path=ppt/slides/slide4.xml><?xml version="1.0" encoding="utf-8"?>
+<p:sld xmlns:a="http://schemas.openxmlformats.org/drawingml/2006/main" xmlns:r="http://schemas.openxmlformats.org/officeDocument/2006/relationships" xmlns:p="http://schemas.openxmlformats.org/presentationml/2006/main">
+  <p:cSld>
+    <p:spTree>
+      <p:nvGrpSpPr>
+        <p:cNvPr id="1" name=""/>
+        <p:cNvGrpSpPr/>
+        <p:nvPr/>
+      </p:nvGrpSpPr>
+      <p:grpSpPr>
+        <a:xfrm>
+          <a:off x="0" y="0"/>
+          <a:ext cx="0" cy="0"/>
+          <a:chOff x="0" y="0"/>
+          <a:chExt cx="0" cy="0"/>
+        </a:xfrm>
+      </p:grpSpPr>
+      <p:sp>
+        <p:nvSpPr>
+          <p:cNvPr id="2" name="Title 1">
+            <a:extLst>
+              <a:ext uri="{FF2B5EF4-FFF2-40B4-BE49-F238E27FC236}">
+                <a16:creationId xmlns:a16="http://schemas.microsoft.com/office/drawing/2014/main" id="{9B2EDE5B-FF14-7646-7A1F-49B8E3A50699}"/>
+              </a:ext>
+            </a:extLst>
+          </p:cNvPr>
+          <p:cNvSpPr>
+            <a:spLocks noGrp="1"/>
+          </p:cNvSpPr>
+          <p:nvPr>
+            <p:ph type="title"/>
+          </p:nvPr>
+        </p:nvSpPr>
+        <p:spPr/>
+        <p:txBody>
+          <a:bodyPr/>
+          <a:lstStyle/>
+          <a:p>
+            <a:r>
+              <a:rPr lang="de-CH" dirty="0" err="1"/>
+              <a:t>Causal</a:t>
+            </a:r>
+            <a:r>
+              <a:rPr lang="de-CH" dirty="0"/>
+              <a:t> </a:t>
+            </a:r>
+            <a:r>
+              <a:rPr lang="de-CH" dirty="0" err="1"/>
+              <a:t>Reasoning</a:t>
+            </a:r>
+            <a:endParaRPr lang="en-CH" dirty="0"/>
+          </a:p>
+        </p:txBody>
+      </p:sp>
+      <p:sp>
+        <p:nvSpPr>
+          <p:cNvPr id="3" name="Content Placeholder 2">
+            <a:extLst>
+              <a:ext uri="{FF2B5EF4-FFF2-40B4-BE49-F238E27FC236}">
+                <a16:creationId xmlns:a16="http://schemas.microsoft.com/office/drawing/2014/main" id="{E02D3514-E1F8-A44C-72EC-82AA96464F45}"/>
+              </a:ext>
+            </a:extLst>
+          </p:cNvPr>
+          <p:cNvSpPr>
+            <a:spLocks noGrp="1"/>
+          </p:cNvSpPr>
+          <p:nvPr>
+            <p:ph idx="1"/>
+          </p:nvPr>
+        </p:nvSpPr>
+        <p:spPr/>
+        <p:txBody>
+          <a:bodyPr/>
+          <a:lstStyle/>
+          <a:p>
+            <a:r>
+              <a:rPr lang="de-CH" dirty="0"/>
+              <a:t>DAGs, etc…</a:t>
+            </a:r>
+          </a:p>
+          <a:p>
+            <a:pPr marL="0" indent="0">
+              <a:buNone/>
+            </a:pPr>
+            <a:endParaRPr lang="en-CH" dirty="0"/>
+          </a:p>
+        </p:txBody>
+      </p:sp>
+    </p:spTree>
+    <p:extLst>
+      <p:ext uri="{BB962C8B-B14F-4D97-AF65-F5344CB8AC3E}">
+        <p14:creationId xmlns:p14="http://schemas.microsoft.com/office/powerpoint/2010/main" val="1546665739"/>
+      </p:ext>
+    </p:extLst>
+  </p:cSld>
+  <p:clrMapOvr>
+    <a:masterClrMapping/>
+  </p:clrMapOvr>
+</p:sld>
+</file>
+
+<file path=ppt/slides/slide5.xml><?xml version="1.0" encoding="utf-8"?>
+<p:sld xmlns:a="http://schemas.openxmlformats.org/drawingml/2006/main" xmlns:r="http://schemas.openxmlformats.org/officeDocument/2006/relationships" xmlns:p="http://schemas.openxmlformats.org/presentationml/2006/main">
+  <p:cSld>
+    <p:spTree>
+      <p:nvGrpSpPr>
+        <p:cNvPr id="1" name=""/>
+        <p:cNvGrpSpPr/>
+        <p:nvPr/>
+      </p:nvGrpSpPr>
+      <p:grpSpPr>
+        <a:xfrm>
+          <a:off x="0" y="0"/>
+          <a:ext cx="0" cy="0"/>
+          <a:chOff x="0" y="0"/>
+          <a:chExt cx="0" cy="0"/>
+        </a:xfrm>
+      </p:grpSpPr>
+      <p:sp>
+        <p:nvSpPr>
+          <p:cNvPr id="2" name="Title 1">
+            <a:extLst>
+              <a:ext uri="{FF2B5EF4-FFF2-40B4-BE49-F238E27FC236}">
+                <a16:creationId xmlns:a16="http://schemas.microsoft.com/office/drawing/2014/main" id="{59807686-857B-4667-FD35-484CD1486A6C}"/>
+              </a:ext>
+            </a:extLst>
+          </p:cNvPr>
+          <p:cNvSpPr>
+            <a:spLocks noGrp="1"/>
+          </p:cNvSpPr>
+          <p:nvPr>
+            <p:ph type="title"/>
+          </p:nvPr>
+        </p:nvSpPr>
+        <p:spPr/>
+        <p:txBody>
+          <a:bodyPr/>
+          <a:lstStyle/>
+          <a:p>
+            <a:r>
+              <a:rPr lang="de-CH" dirty="0"/>
+              <a:t>Transparency and </a:t>
+            </a:r>
+            <a:r>
+              <a:rPr lang="de-CH" dirty="0" err="1"/>
+              <a:t>Reproducibility</a:t>
+            </a:r>
+            <a:endParaRPr lang="en-CH" dirty="0"/>
+          </a:p>
+        </p:txBody>
+      </p:sp>
+      <p:pic>
+        <p:nvPicPr>
+          <p:cNvPr id="5" name="Content Placeholder 4">
+            <a:extLst>
+              <a:ext uri="{FF2B5EF4-FFF2-40B4-BE49-F238E27FC236}">
+                <a16:creationId xmlns:a16="http://schemas.microsoft.com/office/drawing/2014/main" id="{26648917-2D3F-6DC0-C0A5-CEA1CCDF4979}"/>
+              </a:ext>
+            </a:extLst>
+          </p:cNvPr>
+          <p:cNvPicPr>
+            <a:picLocks noGrp="1" noChangeAspect="1"/>
+          </p:cNvPicPr>
+          <p:nvPr>
+            <p:ph idx="1"/>
+          </p:nvPr>
+        </p:nvPicPr>
+        <p:blipFill>
+          <a:blip r:embed="rId2"/>
+          <a:stretch>
+            <a:fillRect/>
+          </a:stretch>
+        </p:blipFill>
+        <p:spPr>
+          <a:xfrm>
+            <a:off x="0" y="1533229"/>
+            <a:ext cx="6788353" cy="4351338"/>
+          </a:xfrm>
+          <a:prstGeom prst="rect">
+            <a:avLst/>
+          </a:prstGeom>
+        </p:spPr>
+      </p:pic>
+    </p:spTree>
+    <p:extLst>
+      <p:ext uri="{BB962C8B-B14F-4D97-AF65-F5344CB8AC3E}">
+        <p14:creationId xmlns:p14="http://schemas.microsoft.com/office/powerpoint/2010/main" val="2573603863"/>
       </p:ext>
     </p:extLst>
   </p:cSld>

</xml_diff>

<commit_message>
completed presentation structure, created directory for storing comments on analyses
</commit_message>
<xml_diff>
--- a/presentation/miniproject_presentation.pptx
+++ b/presentation/miniproject_presentation.pptx
@@ -10,6 +10,8 @@
     <p:sldId id="258" r:id="rId4"/>
     <p:sldId id="259" r:id="rId5"/>
     <p:sldId id="260" r:id="rId6"/>
+    <p:sldId id="261" r:id="rId7"/>
+    <p:sldId id="262" r:id="rId8"/>
   </p:sldIdLst>
   <p:sldSz cx="12192000" cy="6858000"/>
   <p:notesSz cx="6858000" cy="9144000"/>
@@ -119,7 +121,7 @@
 <file path=ppt/revisionInfo.xml><?xml version="1.0" encoding="utf-8"?>
 <p1510:revInfo xmlns:a="http://schemas.openxmlformats.org/drawingml/2006/main" xmlns:r="http://schemas.openxmlformats.org/officeDocument/2006/relationships" xmlns:p1510="http://schemas.microsoft.com/office/powerpoint/2015/10/main">
   <p1510:revLst>
-    <p1510:client id="{B81A0D32-7048-4EBC-999B-B8680BBC1F6E}" v="2" dt="2026-04-29T14:13:22.444"/>
+    <p1510:client id="{B81A0D32-7048-4EBC-999B-B8680BBC1F6E}" v="3" dt="2026-04-29T14:25:02.172"/>
   </p1510:revLst>
 </p1510:revInfo>
 </file>
@@ -129,12 +131,12 @@
   <pc:docChgLst>
     <pc:chgData name="tpayer27@gmail.com" userId="7e90483bd88d641e" providerId="LiveId" clId="{33B4280C-14B8-46FE-96E8-14997B42EB38}"/>
     <pc:docChg chg="undo custSel addSld modSld">
-      <pc:chgData name="tpayer27@gmail.com" userId="7e90483bd88d641e" providerId="LiveId" clId="{33B4280C-14B8-46FE-96E8-14997B42EB38}" dt="2026-04-29T14:20:18.640" v="700" actId="1076"/>
+      <pc:chgData name="tpayer27@gmail.com" userId="7e90483bd88d641e" providerId="LiveId" clId="{33B4280C-14B8-46FE-96E8-14997B42EB38}" dt="2026-04-29T14:51:53.229" v="1108" actId="20577"/>
       <pc:docMkLst>
         <pc:docMk/>
       </pc:docMkLst>
       <pc:sldChg chg="modSp mod">
-        <pc:chgData name="tpayer27@gmail.com" userId="7e90483bd88d641e" providerId="LiveId" clId="{33B4280C-14B8-46FE-96E8-14997B42EB38}" dt="2026-04-29T14:18:23.395" v="511" actId="5793"/>
+        <pc:chgData name="tpayer27@gmail.com" userId="7e90483bd88d641e" providerId="LiveId" clId="{33B4280C-14B8-46FE-96E8-14997B42EB38}" dt="2026-04-29T14:50:10.320" v="1077" actId="20577"/>
         <pc:sldMkLst>
           <pc:docMk/>
           <pc:sldMk cId="568311737" sldId="257"/>
@@ -148,7 +150,7 @@
           </ac:spMkLst>
         </pc:spChg>
         <pc:spChg chg="mod">
-          <ac:chgData name="tpayer27@gmail.com" userId="7e90483bd88d641e" providerId="LiveId" clId="{33B4280C-14B8-46FE-96E8-14997B42EB38}" dt="2026-04-29T14:18:23.395" v="511" actId="5793"/>
+          <ac:chgData name="tpayer27@gmail.com" userId="7e90483bd88d641e" providerId="LiveId" clId="{33B4280C-14B8-46FE-96E8-14997B42EB38}" dt="2026-04-29T14:50:10.320" v="1077" actId="20577"/>
           <ac:spMkLst>
             <pc:docMk/>
             <pc:sldMk cId="568311737" sldId="257"/>
@@ -157,7 +159,7 @@
         </pc:spChg>
       </pc:sldChg>
       <pc:sldChg chg="modSp new mod">
-        <pc:chgData name="tpayer27@gmail.com" userId="7e90483bd88d641e" providerId="LiveId" clId="{33B4280C-14B8-46FE-96E8-14997B42EB38}" dt="2026-04-29T14:18:34.595" v="551" actId="20577"/>
+        <pc:chgData name="tpayer27@gmail.com" userId="7e90483bd88d641e" providerId="LiveId" clId="{33B4280C-14B8-46FE-96E8-14997B42EB38}" dt="2026-04-29T14:24:17.202" v="756" actId="5793"/>
         <pc:sldMkLst>
           <pc:docMk/>
           <pc:sldMk cId="401316806" sldId="258"/>
@@ -168,6 +170,14 @@
             <pc:docMk/>
             <pc:sldMk cId="401316806" sldId="258"/>
             <ac:spMk id="2" creationId="{A8ED7CDF-D330-A82F-973B-4B6B36C09665}"/>
+          </ac:spMkLst>
+        </pc:spChg>
+        <pc:spChg chg="mod">
+          <ac:chgData name="tpayer27@gmail.com" userId="7e90483bd88d641e" providerId="LiveId" clId="{33B4280C-14B8-46FE-96E8-14997B42EB38}" dt="2026-04-29T14:24:17.202" v="756" actId="5793"/>
+          <ac:spMkLst>
+            <pc:docMk/>
+            <pc:sldMk cId="401316806" sldId="258"/>
+            <ac:spMk id="3" creationId="{5CF9183D-445C-25C4-6291-EDF4CDACBE96}"/>
           </ac:spMkLst>
         </pc:spChg>
       </pc:sldChg>
@@ -195,7 +205,7 @@
         </pc:spChg>
       </pc:sldChg>
       <pc:sldChg chg="addSp delSp modSp new mod">
-        <pc:chgData name="tpayer27@gmail.com" userId="7e90483bd88d641e" providerId="LiveId" clId="{33B4280C-14B8-46FE-96E8-14997B42EB38}" dt="2026-04-29T14:20:18.640" v="700" actId="1076"/>
+        <pc:chgData name="tpayer27@gmail.com" userId="7e90483bd88d641e" providerId="LiveId" clId="{33B4280C-14B8-46FE-96E8-14997B42EB38}" dt="2026-04-29T14:29:00.590" v="933" actId="20577"/>
         <pc:sldMkLst>
           <pc:docMk/>
           <pc:sldMk cId="2573603863" sldId="260"/>
@@ -216,6 +226,14 @@
             <ac:spMk id="3" creationId="{4ED97D5A-69CA-43A5-F539-61D03C119579}"/>
           </ac:spMkLst>
         </pc:spChg>
+        <pc:spChg chg="add mod">
+          <ac:chgData name="tpayer27@gmail.com" userId="7e90483bd88d641e" providerId="LiveId" clId="{33B4280C-14B8-46FE-96E8-14997B42EB38}" dt="2026-04-29T14:29:00.590" v="933" actId="20577"/>
+          <ac:spMkLst>
+            <pc:docMk/>
+            <pc:sldMk cId="2573603863" sldId="260"/>
+            <ac:spMk id="11" creationId="{3C368489-ACDA-5050-D840-05E08B9EC190}"/>
+          </ac:spMkLst>
+        </pc:spChg>
         <pc:picChg chg="add mod ord">
           <ac:chgData name="tpayer27@gmail.com" userId="7e90483bd88d641e" providerId="LiveId" clId="{33B4280C-14B8-46FE-96E8-14997B42EB38}" dt="2026-04-29T14:20:18.640" v="700" actId="1076"/>
           <ac:picMkLst>
@@ -224,6 +242,60 @@
             <ac:picMk id="5" creationId="{26648917-2D3F-6DC0-C0A5-CEA1CCDF4979}"/>
           </ac:picMkLst>
         </pc:picChg>
+        <pc:picChg chg="add mod">
+          <ac:chgData name="tpayer27@gmail.com" userId="7e90483bd88d641e" providerId="LiveId" clId="{33B4280C-14B8-46FE-96E8-14997B42EB38}" dt="2026-04-29T14:23:53.475" v="712" actId="1076"/>
+          <ac:picMkLst>
+            <pc:docMk/>
+            <pc:sldMk cId="2573603863" sldId="260"/>
+            <ac:picMk id="7" creationId="{6DA10D87-A3BC-3D82-7B6D-168F7106B663}"/>
+          </ac:picMkLst>
+        </pc:picChg>
+        <pc:cxnChg chg="add mod">
+          <ac:chgData name="tpayer27@gmail.com" userId="7e90483bd88d641e" providerId="LiveId" clId="{33B4280C-14B8-46FE-96E8-14997B42EB38}" dt="2026-04-29T14:27:18.856" v="901" actId="14100"/>
+          <ac:cxnSpMkLst>
+            <pc:docMk/>
+            <pc:sldMk cId="2573603863" sldId="260"/>
+            <ac:cxnSpMk id="9" creationId="{294DB138-1EC6-538F-8DD8-02BB258F8941}"/>
+          </ac:cxnSpMkLst>
+        </pc:cxnChg>
+      </pc:sldChg>
+      <pc:sldChg chg="modSp new mod">
+        <pc:chgData name="tpayer27@gmail.com" userId="7e90483bd88d641e" providerId="LiveId" clId="{33B4280C-14B8-46FE-96E8-14997B42EB38}" dt="2026-04-29T14:49:10.969" v="1039" actId="20577"/>
+        <pc:sldMkLst>
+          <pc:docMk/>
+          <pc:sldMk cId="3738012847" sldId="261"/>
+        </pc:sldMkLst>
+        <pc:spChg chg="mod">
+          <ac:chgData name="tpayer27@gmail.com" userId="7e90483bd88d641e" providerId="LiveId" clId="{33B4280C-14B8-46FE-96E8-14997B42EB38}" dt="2026-04-29T14:47:53.710" v="954" actId="20577"/>
+          <ac:spMkLst>
+            <pc:docMk/>
+            <pc:sldMk cId="3738012847" sldId="261"/>
+            <ac:spMk id="2" creationId="{FFE019AF-14F3-8BBB-6D3F-BC3ADFB90729}"/>
+          </ac:spMkLst>
+        </pc:spChg>
+        <pc:spChg chg="mod">
+          <ac:chgData name="tpayer27@gmail.com" userId="7e90483bd88d641e" providerId="LiveId" clId="{33B4280C-14B8-46FE-96E8-14997B42EB38}" dt="2026-04-29T14:49:10.969" v="1039" actId="20577"/>
+          <ac:spMkLst>
+            <pc:docMk/>
+            <pc:sldMk cId="3738012847" sldId="261"/>
+            <ac:spMk id="3" creationId="{82D9D260-2761-E4EE-F884-D4F7769E696F}"/>
+          </ac:spMkLst>
+        </pc:spChg>
+      </pc:sldChg>
+      <pc:sldChg chg="modSp new mod">
+        <pc:chgData name="tpayer27@gmail.com" userId="7e90483bd88d641e" providerId="LiveId" clId="{33B4280C-14B8-46FE-96E8-14997B42EB38}" dt="2026-04-29T14:51:53.229" v="1108" actId="20577"/>
+        <pc:sldMkLst>
+          <pc:docMk/>
+          <pc:sldMk cId="3978538866" sldId="262"/>
+        </pc:sldMkLst>
+        <pc:spChg chg="mod">
+          <ac:chgData name="tpayer27@gmail.com" userId="7e90483bd88d641e" providerId="LiveId" clId="{33B4280C-14B8-46FE-96E8-14997B42EB38}" dt="2026-04-29T14:51:53.229" v="1108" actId="20577"/>
+          <ac:spMkLst>
+            <pc:docMk/>
+            <pc:sldMk cId="3978538866" sldId="262"/>
+            <ac:spMk id="2" creationId="{3907596B-4792-8F17-1652-319FEB91C8EF}"/>
+          </ac:spMkLst>
+        </pc:spChg>
       </pc:sldChg>
     </pc:docChg>
   </pc:docChgLst>
@@ -3677,8 +3749,11 @@
           <a:p>
             <a:r>
               <a:rPr lang="en-US" dirty="0"/>
-              <a:t>Principles of GRP</a:t>
-            </a:r>
+              <a:t>Fulfillment of GRP principles</a:t>
+            </a:r>
+          </a:p>
+          <a:p>
+            <a:endParaRPr lang="en-US" dirty="0"/>
           </a:p>
           <a:p>
             <a:pPr marL="0" indent="0">
@@ -3784,7 +3859,11 @@
           <a:bodyPr/>
           <a:lstStyle/>
           <a:p>
-            <a:endParaRPr lang="en-CH"/>
+            <a:r>
+              <a:rPr lang="de-CH" dirty="0"/>
+              <a:t>Summary, etc…</a:t>
+            </a:r>
+            <a:endParaRPr lang="en-CH" dirty="0"/>
           </a:p>
         </p:txBody>
       </p:sp>
@@ -3984,10 +4063,478 @@
           </a:prstGeom>
         </p:spPr>
       </p:pic>
+      <p:pic>
+        <p:nvPicPr>
+          <p:cNvPr id="7" name="Picture 6">
+            <a:extLst>
+              <a:ext uri="{FF2B5EF4-FFF2-40B4-BE49-F238E27FC236}">
+                <a16:creationId xmlns:a16="http://schemas.microsoft.com/office/drawing/2014/main" id="{6DA10D87-A3BC-3D82-7B6D-168F7106B663}"/>
+              </a:ext>
+            </a:extLst>
+          </p:cNvPr>
+          <p:cNvPicPr>
+            <a:picLocks noChangeAspect="1"/>
+          </p:cNvPicPr>
+          <p:nvPr/>
+        </p:nvPicPr>
+        <p:blipFill>
+          <a:blip r:embed="rId3"/>
+          <a:stretch>
+            <a:fillRect/>
+          </a:stretch>
+        </p:blipFill>
+        <p:spPr>
+          <a:xfrm>
+            <a:off x="8689225" y="1065637"/>
+            <a:ext cx="2381040" cy="5286522"/>
+          </a:xfrm>
+          <a:prstGeom prst="rect">
+            <a:avLst/>
+          </a:prstGeom>
+        </p:spPr>
+      </p:pic>
+      <p:cxnSp>
+        <p:nvCxnSpPr>
+          <p:cNvPr id="9" name="Straight Arrow Connector 8">
+            <a:extLst>
+              <a:ext uri="{FF2B5EF4-FFF2-40B4-BE49-F238E27FC236}">
+                <a16:creationId xmlns:a16="http://schemas.microsoft.com/office/drawing/2014/main" id="{294DB138-1EC6-538F-8DD8-02BB258F8941}"/>
+              </a:ext>
+            </a:extLst>
+          </p:cNvPr>
+          <p:cNvCxnSpPr>
+            <a:cxnSpLocks/>
+            <a:stCxn id="5" idx="3"/>
+            <a:endCxn id="7" idx="1"/>
+          </p:cNvCxnSpPr>
+          <p:nvPr/>
+        </p:nvCxnSpPr>
+        <p:spPr>
+          <a:xfrm>
+            <a:off x="6788353" y="3708898"/>
+            <a:ext cx="1900872" cy="0"/>
+          </a:xfrm>
+          <a:prstGeom prst="straightConnector1">
+            <a:avLst/>
+          </a:prstGeom>
+          <a:ln>
+            <a:tailEnd type="triangle"/>
+          </a:ln>
+        </p:spPr>
+        <p:style>
+          <a:lnRef idx="2">
+            <a:schemeClr val="accent1"/>
+          </a:lnRef>
+          <a:fillRef idx="0">
+            <a:schemeClr val="accent1"/>
+          </a:fillRef>
+          <a:effectRef idx="1">
+            <a:schemeClr val="accent1"/>
+          </a:effectRef>
+          <a:fontRef idx="minor">
+            <a:schemeClr val="tx1"/>
+          </a:fontRef>
+        </p:style>
+      </p:cxnSp>
+      <p:sp>
+        <p:nvSpPr>
+          <p:cNvPr id="11" name="TextBox 10">
+            <a:extLst>
+              <a:ext uri="{FF2B5EF4-FFF2-40B4-BE49-F238E27FC236}">
+                <a16:creationId xmlns:a16="http://schemas.microsoft.com/office/drawing/2014/main" id="{3C368489-ACDA-5050-D840-05E08B9EC190}"/>
+              </a:ext>
+            </a:extLst>
+          </p:cNvPr>
+          <p:cNvSpPr txBox="1"/>
+          <p:nvPr/>
+        </p:nvSpPr>
+        <p:spPr>
+          <a:xfrm>
+            <a:off x="0" y="5993459"/>
+            <a:ext cx="8689225" cy="646331"/>
+          </a:xfrm>
+          <a:prstGeom prst="rect">
+            <a:avLst/>
+          </a:prstGeom>
+          <a:noFill/>
+        </p:spPr>
+        <p:txBody>
+          <a:bodyPr wrap="square" rtlCol="0">
+            <a:spAutoFit/>
+          </a:bodyPr>
+          <a:lstStyle/>
+          <a:p>
+            <a:r>
+              <a:rPr lang="de-CH" dirty="0"/>
+              <a:t>Note: </a:t>
+            </a:r>
+            <a:r>
+              <a:rPr lang="de-CH" dirty="0" err="1"/>
+              <a:t>the</a:t>
+            </a:r>
+            <a:r>
+              <a:rPr lang="de-CH" dirty="0"/>
+              <a:t> </a:t>
+            </a:r>
+            <a:r>
+              <a:rPr lang="de-CH" dirty="0" err="1"/>
+              <a:t>above</a:t>
+            </a:r>
+            <a:r>
+              <a:rPr lang="de-CH" dirty="0"/>
+              <a:t> </a:t>
+            </a:r>
+            <a:r>
+              <a:rPr lang="de-CH" dirty="0" err="1"/>
+              <a:t>illustration</a:t>
+            </a:r>
+            <a:r>
+              <a:rPr lang="de-CH" dirty="0"/>
+              <a:t> </a:t>
+            </a:r>
+            <a:r>
+              <a:rPr lang="de-CH" dirty="0" err="1"/>
+              <a:t>is</a:t>
+            </a:r>
+            <a:r>
+              <a:rPr lang="de-CH" dirty="0"/>
+              <a:t> just </a:t>
+            </a:r>
+            <a:r>
+              <a:rPr lang="de-CH" dirty="0" err="1"/>
+              <a:t>to</a:t>
+            </a:r>
+            <a:r>
+              <a:rPr lang="de-CH" dirty="0"/>
+              <a:t> </a:t>
+            </a:r>
+            <a:r>
+              <a:rPr lang="de-CH" dirty="0" err="1"/>
+              <a:t>show</a:t>
+            </a:r>
+            <a:r>
+              <a:rPr lang="de-CH" dirty="0"/>
+              <a:t> </a:t>
+            </a:r>
+            <a:r>
+              <a:rPr lang="de-CH" dirty="0" err="1"/>
+              <a:t>what</a:t>
+            </a:r>
+            <a:r>
+              <a:rPr lang="de-CH" dirty="0"/>
+              <a:t> I </a:t>
+            </a:r>
+            <a:r>
+              <a:rPr lang="de-CH" dirty="0" err="1"/>
+              <a:t>want</a:t>
+            </a:r>
+            <a:r>
+              <a:rPr lang="de-CH" dirty="0"/>
+              <a:t> </a:t>
+            </a:r>
+            <a:r>
+              <a:rPr lang="de-CH" dirty="0" err="1"/>
+              <a:t>to</a:t>
+            </a:r>
+            <a:r>
+              <a:rPr lang="de-CH" dirty="0"/>
+              <a:t> </a:t>
+            </a:r>
+            <a:r>
+              <a:rPr lang="de-CH" dirty="0" err="1"/>
+              <a:t>include</a:t>
+            </a:r>
+            <a:r>
+              <a:rPr lang="de-CH" dirty="0"/>
+              <a:t> in </a:t>
+            </a:r>
+            <a:r>
+              <a:rPr lang="de-CH" dirty="0" err="1"/>
+              <a:t>this</a:t>
+            </a:r>
+            <a:r>
+              <a:rPr lang="de-CH" dirty="0"/>
+              <a:t> </a:t>
+            </a:r>
+            <a:r>
+              <a:rPr lang="de-CH" dirty="0" err="1"/>
+              <a:t>slide</a:t>
+            </a:r>
+            <a:r>
+              <a:rPr lang="de-CH" dirty="0"/>
+              <a:t>, </a:t>
+            </a:r>
+            <a:r>
+              <a:rPr lang="de-CH" dirty="0" err="1"/>
+              <a:t>screenshots</a:t>
+            </a:r>
+            <a:r>
+              <a:rPr lang="de-CH" dirty="0"/>
+              <a:t> </a:t>
+            </a:r>
+            <a:r>
+              <a:rPr lang="de-CH" dirty="0" err="1"/>
+              <a:t>need</a:t>
+            </a:r>
+            <a:r>
+              <a:rPr lang="de-CH" dirty="0"/>
+              <a:t> </a:t>
+            </a:r>
+            <a:r>
+              <a:rPr lang="de-CH" dirty="0" err="1"/>
+              <a:t>to</a:t>
+            </a:r>
+            <a:r>
+              <a:rPr lang="de-CH" dirty="0"/>
+              <a:t> </a:t>
+            </a:r>
+            <a:r>
+              <a:rPr lang="de-CH" dirty="0" err="1"/>
+              <a:t>be</a:t>
+            </a:r>
+            <a:r>
+              <a:rPr lang="de-CH" dirty="0"/>
+              <a:t> </a:t>
+            </a:r>
+            <a:r>
+              <a:rPr lang="de-CH" dirty="0" err="1"/>
+              <a:t>taken</a:t>
+            </a:r>
+            <a:r>
+              <a:rPr lang="de-CH" dirty="0"/>
+              <a:t> </a:t>
+            </a:r>
+            <a:r>
+              <a:rPr lang="de-CH" dirty="0" err="1"/>
+              <a:t>again</a:t>
+            </a:r>
+            <a:r>
+              <a:rPr lang="de-CH" dirty="0"/>
+              <a:t> </a:t>
+            </a:r>
+            <a:endParaRPr lang="en-CH" dirty="0"/>
+          </a:p>
+        </p:txBody>
+      </p:sp>
     </p:spTree>
     <p:extLst>
       <p:ext uri="{BB962C8B-B14F-4D97-AF65-F5344CB8AC3E}">
         <p14:creationId xmlns:p14="http://schemas.microsoft.com/office/powerpoint/2010/main" val="2573603863"/>
+      </p:ext>
+    </p:extLst>
+  </p:cSld>
+  <p:clrMapOvr>
+    <a:masterClrMapping/>
+  </p:clrMapOvr>
+</p:sld>
+</file>
+
+<file path=ppt/slides/slide6.xml><?xml version="1.0" encoding="utf-8"?>
+<p:sld xmlns:a="http://schemas.openxmlformats.org/drawingml/2006/main" xmlns:r="http://schemas.openxmlformats.org/officeDocument/2006/relationships" xmlns:p="http://schemas.openxmlformats.org/presentationml/2006/main">
+  <p:cSld>
+    <p:spTree>
+      <p:nvGrpSpPr>
+        <p:cNvPr id="1" name=""/>
+        <p:cNvGrpSpPr/>
+        <p:nvPr/>
+      </p:nvGrpSpPr>
+      <p:grpSpPr>
+        <a:xfrm>
+          <a:off x="0" y="0"/>
+          <a:ext cx="0" cy="0"/>
+          <a:chOff x="0" y="0"/>
+          <a:chExt cx="0" cy="0"/>
+        </a:xfrm>
+      </p:grpSpPr>
+      <p:sp>
+        <p:nvSpPr>
+          <p:cNvPr id="2" name="Title 1">
+            <a:extLst>
+              <a:ext uri="{FF2B5EF4-FFF2-40B4-BE49-F238E27FC236}">
+                <a16:creationId xmlns:a16="http://schemas.microsoft.com/office/drawing/2014/main" id="{FFE019AF-14F3-8BBB-6D3F-BC3ADFB90729}"/>
+              </a:ext>
+            </a:extLst>
+          </p:cNvPr>
+          <p:cNvSpPr>
+            <a:spLocks noGrp="1"/>
+          </p:cNvSpPr>
+          <p:nvPr>
+            <p:ph type="title"/>
+          </p:nvPr>
+        </p:nvSpPr>
+        <p:spPr/>
+        <p:txBody>
+          <a:bodyPr/>
+          <a:lstStyle/>
+          <a:p>
+            <a:r>
+              <a:rPr lang="de-CH" dirty="0"/>
+              <a:t>Soundness </a:t>
+            </a:r>
+            <a:r>
+              <a:rPr lang="de-CH" dirty="0" err="1"/>
+              <a:t>of</a:t>
+            </a:r>
+            <a:r>
+              <a:rPr lang="de-CH" dirty="0"/>
+              <a:t> </a:t>
+            </a:r>
+            <a:r>
+              <a:rPr lang="de-CH" dirty="0" err="1"/>
+              <a:t>Analyses</a:t>
+            </a:r>
+            <a:endParaRPr lang="en-CH" dirty="0"/>
+          </a:p>
+        </p:txBody>
+      </p:sp>
+      <p:sp>
+        <p:nvSpPr>
+          <p:cNvPr id="3" name="Content Placeholder 2">
+            <a:extLst>
+              <a:ext uri="{FF2B5EF4-FFF2-40B4-BE49-F238E27FC236}">
+                <a16:creationId xmlns:a16="http://schemas.microsoft.com/office/drawing/2014/main" id="{82D9D260-2761-E4EE-F884-D4F7769E696F}"/>
+              </a:ext>
+            </a:extLst>
+          </p:cNvPr>
+          <p:cNvSpPr>
+            <a:spLocks noGrp="1"/>
+          </p:cNvSpPr>
+          <p:nvPr>
+            <p:ph idx="1"/>
+          </p:nvPr>
+        </p:nvSpPr>
+        <p:spPr/>
+        <p:txBody>
+          <a:bodyPr/>
+          <a:lstStyle/>
+          <a:p>
+            <a:r>
+              <a:rPr lang="de-CH" dirty="0"/>
+              <a:t>Comments_on_analyses/timo.md</a:t>
+            </a:r>
+          </a:p>
+          <a:p>
+            <a:r>
+              <a:rPr lang="de-CH" dirty="0"/>
+              <a:t>Comments_on_analyses/mati.md</a:t>
+            </a:r>
+          </a:p>
+          <a:p>
+            <a:r>
+              <a:rPr lang="de-CH" dirty="0" err="1"/>
+              <a:t>Comparison</a:t>
+            </a:r>
+            <a:endParaRPr lang="de-CH" dirty="0"/>
+          </a:p>
+          <a:p>
+            <a:r>
+              <a:rPr lang="de-CH" dirty="0" err="1"/>
+              <a:t>etc</a:t>
+            </a:r>
+            <a:endParaRPr lang="en-CH" dirty="0"/>
+          </a:p>
+        </p:txBody>
+      </p:sp>
+    </p:spTree>
+    <p:extLst>
+      <p:ext uri="{BB962C8B-B14F-4D97-AF65-F5344CB8AC3E}">
+        <p14:creationId xmlns:p14="http://schemas.microsoft.com/office/powerpoint/2010/main" val="3738012847"/>
+      </p:ext>
+    </p:extLst>
+  </p:cSld>
+  <p:clrMapOvr>
+    <a:masterClrMapping/>
+  </p:clrMapOvr>
+</p:sld>
+</file>
+
+<file path=ppt/slides/slide7.xml><?xml version="1.0" encoding="utf-8"?>
+<p:sld xmlns:a="http://schemas.openxmlformats.org/drawingml/2006/main" xmlns:r="http://schemas.openxmlformats.org/officeDocument/2006/relationships" xmlns:p="http://schemas.openxmlformats.org/presentationml/2006/main">
+  <p:cSld>
+    <p:spTree>
+      <p:nvGrpSpPr>
+        <p:cNvPr id="1" name=""/>
+        <p:cNvGrpSpPr/>
+        <p:nvPr/>
+      </p:nvGrpSpPr>
+      <p:grpSpPr>
+        <a:xfrm>
+          <a:off x="0" y="0"/>
+          <a:ext cx="0" cy="0"/>
+          <a:chOff x="0" y="0"/>
+          <a:chExt cx="0" cy="0"/>
+        </a:xfrm>
+      </p:grpSpPr>
+      <p:sp>
+        <p:nvSpPr>
+          <p:cNvPr id="2" name="Title 1">
+            <a:extLst>
+              <a:ext uri="{FF2B5EF4-FFF2-40B4-BE49-F238E27FC236}">
+                <a16:creationId xmlns:a16="http://schemas.microsoft.com/office/drawing/2014/main" id="{3907596B-4792-8F17-1652-319FEB91C8EF}"/>
+              </a:ext>
+            </a:extLst>
+          </p:cNvPr>
+          <p:cNvSpPr>
+            <a:spLocks noGrp="1"/>
+          </p:cNvSpPr>
+          <p:nvPr>
+            <p:ph type="title"/>
+          </p:nvPr>
+        </p:nvSpPr>
+        <p:spPr/>
+        <p:txBody>
+          <a:bodyPr/>
+          <a:lstStyle/>
+          <a:p>
+            <a:r>
+              <a:rPr lang="de-CH" dirty="0"/>
+              <a:t>Fulfillment </a:t>
+            </a:r>
+            <a:r>
+              <a:rPr lang="de-CH" dirty="0" err="1"/>
+              <a:t>of</a:t>
+            </a:r>
+            <a:r>
+              <a:rPr lang="de-CH" dirty="0"/>
+              <a:t> GRP </a:t>
+            </a:r>
+            <a:r>
+              <a:rPr lang="de-CH" dirty="0" err="1"/>
+              <a:t>principles</a:t>
+            </a:r>
+            <a:endParaRPr lang="en-CH" dirty="0"/>
+          </a:p>
+        </p:txBody>
+      </p:sp>
+      <p:sp>
+        <p:nvSpPr>
+          <p:cNvPr id="3" name="Content Placeholder 2">
+            <a:extLst>
+              <a:ext uri="{FF2B5EF4-FFF2-40B4-BE49-F238E27FC236}">
+                <a16:creationId xmlns:a16="http://schemas.microsoft.com/office/drawing/2014/main" id="{64A33FD8-6A2A-0342-4733-5268A07D6817}"/>
+              </a:ext>
+            </a:extLst>
+          </p:cNvPr>
+          <p:cNvSpPr>
+            <a:spLocks noGrp="1"/>
+          </p:cNvSpPr>
+          <p:nvPr>
+            <p:ph idx="1"/>
+          </p:nvPr>
+        </p:nvSpPr>
+        <p:spPr/>
+        <p:txBody>
+          <a:bodyPr/>
+          <a:lstStyle/>
+          <a:p>
+            <a:endParaRPr lang="en-CH"/>
+          </a:p>
+        </p:txBody>
+      </p:sp>
+    </p:spTree>
+    <p:extLst>
+      <p:ext uri="{BB962C8B-B14F-4D97-AF65-F5344CB8AC3E}">
+        <p14:creationId xmlns:p14="http://schemas.microsoft.com/office/powerpoint/2010/main" val="3978538866"/>
       </p:ext>
     </p:extLst>
   </p:cSld>

</xml_diff>

<commit_message>
created R project, made first comments in timo.md
</commit_message>
<xml_diff>
--- a/presentation/miniproject_presentation.pptx
+++ b/presentation/miniproject_presentation.pptx
@@ -10,8 +10,9 @@
     <p:sldId id="258" r:id="rId4"/>
     <p:sldId id="259" r:id="rId5"/>
     <p:sldId id="260" r:id="rId6"/>
-    <p:sldId id="261" r:id="rId7"/>
-    <p:sldId id="262" r:id="rId8"/>
+    <p:sldId id="263" r:id="rId7"/>
+    <p:sldId id="261" r:id="rId8"/>
+    <p:sldId id="262" r:id="rId9"/>
   </p:sldIdLst>
   <p:sldSz cx="12192000" cy="6858000"/>
   <p:notesSz cx="6858000" cy="9144000"/>
@@ -131,7 +132,7 @@
   <pc:docChgLst>
     <pc:chgData name="tpayer27@gmail.com" userId="7e90483bd88d641e" providerId="LiveId" clId="{33B4280C-14B8-46FE-96E8-14997B42EB38}"/>
     <pc:docChg chg="undo custSel addSld modSld">
-      <pc:chgData name="tpayer27@gmail.com" userId="7e90483bd88d641e" providerId="LiveId" clId="{33B4280C-14B8-46FE-96E8-14997B42EB38}" dt="2026-04-29T14:51:53.229" v="1108" actId="20577"/>
+      <pc:chgData name="tpayer27@gmail.com" userId="7e90483bd88d641e" providerId="LiveId" clId="{33B4280C-14B8-46FE-96E8-14997B42EB38}" dt="2026-04-30T07:40:31.175" v="1114" actId="20577"/>
       <pc:docMkLst>
         <pc:docMk/>
       </pc:docMkLst>
@@ -260,7 +261,7 @@
         </pc:cxnChg>
       </pc:sldChg>
       <pc:sldChg chg="modSp new mod">
-        <pc:chgData name="tpayer27@gmail.com" userId="7e90483bd88d641e" providerId="LiveId" clId="{33B4280C-14B8-46FE-96E8-14997B42EB38}" dt="2026-04-29T14:49:10.969" v="1039" actId="20577"/>
+        <pc:chgData name="tpayer27@gmail.com" userId="7e90483bd88d641e" providerId="LiveId" clId="{33B4280C-14B8-46FE-96E8-14997B42EB38}" dt="2026-04-30T07:40:31.175" v="1114" actId="20577"/>
         <pc:sldMkLst>
           <pc:docMk/>
           <pc:sldMk cId="3738012847" sldId="261"/>
@@ -274,7 +275,7 @@
           </ac:spMkLst>
         </pc:spChg>
         <pc:spChg chg="mod">
-          <ac:chgData name="tpayer27@gmail.com" userId="7e90483bd88d641e" providerId="LiveId" clId="{33B4280C-14B8-46FE-96E8-14997B42EB38}" dt="2026-04-29T14:49:10.969" v="1039" actId="20577"/>
+          <ac:chgData name="tpayer27@gmail.com" userId="7e90483bd88d641e" providerId="LiveId" clId="{33B4280C-14B8-46FE-96E8-14997B42EB38}" dt="2026-04-30T07:40:31.175" v="1114" actId="20577"/>
           <ac:spMkLst>
             <pc:docMk/>
             <pc:sldMk cId="3738012847" sldId="261"/>
@@ -296,6 +297,13 @@
             <ac:spMk id="2" creationId="{3907596B-4792-8F17-1652-319FEB91C8EF}"/>
           </ac:spMkLst>
         </pc:spChg>
+      </pc:sldChg>
+      <pc:sldChg chg="new">
+        <pc:chgData name="tpayer27@gmail.com" userId="7e90483bd88d641e" providerId="LiveId" clId="{33B4280C-14B8-46FE-96E8-14997B42EB38}" dt="2026-04-30T07:40:24.729" v="1109" actId="680"/>
+        <pc:sldMkLst>
+          <pc:docMk/>
+          <pc:sldMk cId="2115586794" sldId="263"/>
+        </pc:sldMkLst>
       </pc:sldChg>
     </pc:docChg>
   </pc:docChgLst>
@@ -451,7 +459,7 @@
           <a:p>
             <a:fld id="{2B677C79-E0EF-4BB8-995A-4050F662F273}" type="datetimeFigureOut">
               <a:rPr lang="en-CH" smtClean="0"/>
-              <a:t>29.04.2026</a:t>
+              <a:t>30.04.2026</a:t>
             </a:fld>
             <a:endParaRPr lang="en-CH"/>
           </a:p>
@@ -651,7 +659,7 @@
           <a:p>
             <a:fld id="{2B677C79-E0EF-4BB8-995A-4050F662F273}" type="datetimeFigureOut">
               <a:rPr lang="en-CH" smtClean="0"/>
-              <a:t>29.04.2026</a:t>
+              <a:t>30.04.2026</a:t>
             </a:fld>
             <a:endParaRPr lang="en-CH"/>
           </a:p>
@@ -861,7 +869,7 @@
           <a:p>
             <a:fld id="{2B677C79-E0EF-4BB8-995A-4050F662F273}" type="datetimeFigureOut">
               <a:rPr lang="en-CH" smtClean="0"/>
-              <a:t>29.04.2026</a:t>
+              <a:t>30.04.2026</a:t>
             </a:fld>
             <a:endParaRPr lang="en-CH"/>
           </a:p>
@@ -1061,7 +1069,7 @@
           <a:p>
             <a:fld id="{2B677C79-E0EF-4BB8-995A-4050F662F273}" type="datetimeFigureOut">
               <a:rPr lang="en-CH" smtClean="0"/>
-              <a:t>29.04.2026</a:t>
+              <a:t>30.04.2026</a:t>
             </a:fld>
             <a:endParaRPr lang="en-CH"/>
           </a:p>
@@ -1337,7 +1345,7 @@
           <a:p>
             <a:fld id="{2B677C79-E0EF-4BB8-995A-4050F662F273}" type="datetimeFigureOut">
               <a:rPr lang="en-CH" smtClean="0"/>
-              <a:t>29.04.2026</a:t>
+              <a:t>30.04.2026</a:t>
             </a:fld>
             <a:endParaRPr lang="en-CH"/>
           </a:p>
@@ -1605,7 +1613,7 @@
           <a:p>
             <a:fld id="{2B677C79-E0EF-4BB8-995A-4050F662F273}" type="datetimeFigureOut">
               <a:rPr lang="en-CH" smtClean="0"/>
-              <a:t>29.04.2026</a:t>
+              <a:t>30.04.2026</a:t>
             </a:fld>
             <a:endParaRPr lang="en-CH"/>
           </a:p>
@@ -2020,7 +2028,7 @@
           <a:p>
             <a:fld id="{2B677C79-E0EF-4BB8-995A-4050F662F273}" type="datetimeFigureOut">
               <a:rPr lang="en-CH" smtClean="0"/>
-              <a:t>29.04.2026</a:t>
+              <a:t>30.04.2026</a:t>
             </a:fld>
             <a:endParaRPr lang="en-CH"/>
           </a:p>
@@ -2162,7 +2170,7 @@
           <a:p>
             <a:fld id="{2B677C79-E0EF-4BB8-995A-4050F662F273}" type="datetimeFigureOut">
               <a:rPr lang="en-CH" smtClean="0"/>
-              <a:t>29.04.2026</a:t>
+              <a:t>30.04.2026</a:t>
             </a:fld>
             <a:endParaRPr lang="en-CH"/>
           </a:p>
@@ -2275,7 +2283,7 @@
           <a:p>
             <a:fld id="{2B677C79-E0EF-4BB8-995A-4050F662F273}" type="datetimeFigureOut">
               <a:rPr lang="en-CH" smtClean="0"/>
-              <a:t>29.04.2026</a:t>
+              <a:t>30.04.2026</a:t>
             </a:fld>
             <a:endParaRPr lang="en-CH"/>
           </a:p>
@@ -2588,7 +2596,7 @@
           <a:p>
             <a:fld id="{2B677C79-E0EF-4BB8-995A-4050F662F273}" type="datetimeFigureOut">
               <a:rPr lang="en-CH" smtClean="0"/>
-              <a:t>29.04.2026</a:t>
+              <a:t>30.04.2026</a:t>
             </a:fld>
             <a:endParaRPr lang="en-CH"/>
           </a:p>
@@ -2877,7 +2885,7 @@
           <a:p>
             <a:fld id="{2B677C79-E0EF-4BB8-995A-4050F662F273}" type="datetimeFigureOut">
               <a:rPr lang="en-CH" smtClean="0"/>
-              <a:t>29.04.2026</a:t>
+              <a:t>30.04.2026</a:t>
             </a:fld>
             <a:endParaRPr lang="en-CH"/>
           </a:p>
@@ -3120,7 +3128,7 @@
           <a:p>
             <a:fld id="{2B677C79-E0EF-4BB8-995A-4050F662F273}" type="datetimeFigureOut">
               <a:rPr lang="en-CH" smtClean="0"/>
-              <a:t>29.04.2026</a:t>
+              <a:t>30.04.2026</a:t>
             </a:fld>
             <a:endParaRPr lang="en-CH"/>
           </a:p>
@@ -4351,6 +4359,86 @@
           <p:cNvPr id="2" name="Title 1">
             <a:extLst>
               <a:ext uri="{FF2B5EF4-FFF2-40B4-BE49-F238E27FC236}">
+                <a16:creationId xmlns:a16="http://schemas.microsoft.com/office/drawing/2014/main" id="{7655AC44-6C77-9ED4-9917-CC408BAAF355}"/>
+              </a:ext>
+            </a:extLst>
+          </p:cNvPr>
+          <p:cNvSpPr>
+            <a:spLocks noGrp="1"/>
+          </p:cNvSpPr>
+          <p:nvPr>
+            <p:ph type="title"/>
+          </p:nvPr>
+        </p:nvSpPr>
+        <p:spPr/>
+        <p:txBody>
+          <a:bodyPr/>
+          <a:lstStyle/>
+          <a:p>
+            <a:endParaRPr lang="en-CH"/>
+          </a:p>
+        </p:txBody>
+      </p:sp>
+      <p:sp>
+        <p:nvSpPr>
+          <p:cNvPr id="3" name="Content Placeholder 2">
+            <a:extLst>
+              <a:ext uri="{FF2B5EF4-FFF2-40B4-BE49-F238E27FC236}">
+                <a16:creationId xmlns:a16="http://schemas.microsoft.com/office/drawing/2014/main" id="{C948793F-EC8A-9F93-213A-4C50CD70D795}"/>
+              </a:ext>
+            </a:extLst>
+          </p:cNvPr>
+          <p:cNvSpPr>
+            <a:spLocks noGrp="1"/>
+          </p:cNvSpPr>
+          <p:nvPr>
+            <p:ph idx="1"/>
+          </p:nvPr>
+        </p:nvSpPr>
+        <p:spPr/>
+        <p:txBody>
+          <a:bodyPr/>
+          <a:lstStyle/>
+          <a:p>
+            <a:endParaRPr lang="en-CH"/>
+          </a:p>
+        </p:txBody>
+      </p:sp>
+    </p:spTree>
+    <p:extLst>
+      <p:ext uri="{BB962C8B-B14F-4D97-AF65-F5344CB8AC3E}">
+        <p14:creationId xmlns:p14="http://schemas.microsoft.com/office/powerpoint/2010/main" val="2115586794"/>
+      </p:ext>
+    </p:extLst>
+  </p:cSld>
+  <p:clrMapOvr>
+    <a:masterClrMapping/>
+  </p:clrMapOvr>
+</p:sld>
+</file>
+
+<file path=ppt/slides/slide7.xml><?xml version="1.0" encoding="utf-8"?>
+<p:sld xmlns:a="http://schemas.openxmlformats.org/drawingml/2006/main" xmlns:r="http://schemas.openxmlformats.org/officeDocument/2006/relationships" xmlns:p="http://schemas.openxmlformats.org/presentationml/2006/main">
+  <p:cSld>
+    <p:spTree>
+      <p:nvGrpSpPr>
+        <p:cNvPr id="1" name=""/>
+        <p:cNvGrpSpPr/>
+        <p:nvPr/>
+      </p:nvGrpSpPr>
+      <p:grpSpPr>
+        <a:xfrm>
+          <a:off x="0" y="0"/>
+          <a:ext cx="0" cy="0"/>
+          <a:chOff x="0" y="0"/>
+          <a:chExt cx="0" cy="0"/>
+        </a:xfrm>
+      </p:grpSpPr>
+      <p:sp>
+        <p:nvSpPr>
+          <p:cNvPr id="2" name="Title 1">
+            <a:extLst>
+              <a:ext uri="{FF2B5EF4-FFF2-40B4-BE49-F238E27FC236}">
                 <a16:creationId xmlns:a16="http://schemas.microsoft.com/office/drawing/2014/main" id="{FFE019AF-14F3-8BBB-6D3F-BC3ADFB90729}"/>
               </a:ext>
             </a:extLst>
@@ -4420,6 +4508,12 @@
             </a:r>
           </a:p>
           <a:p>
+            <a:r>
+              <a:rPr lang="de-CH" dirty="0">
+                <a:sym typeface="Wingdings" panose="05000000000000000000" pitchFamily="2" charset="2"/>
+              </a:rPr>
+              <a:t> </a:t>
+            </a:r>
             <a:r>
               <a:rPr lang="de-CH" dirty="0" err="1"/>
               <a:t>Comparison</a:t>
@@ -4448,7 +4542,7 @@
 </p:sld>
 </file>
 
-<file path=ppt/slides/slide7.xml><?xml version="1.0" encoding="utf-8"?>
+<file path=ppt/slides/slide8.xml><?xml version="1.0" encoding="utf-8"?>
 <p:sld xmlns:a="http://schemas.openxmlformats.org/drawingml/2006/main" xmlns:r="http://schemas.openxmlformats.org/officeDocument/2006/relationships" xmlns:p="http://schemas.openxmlformats.org/presentationml/2006/main">
   <p:cSld>
     <p:spTree>

</xml_diff>

<commit_message>
Added analyis 1 presentation slides
</commit_message>
<xml_diff>
--- a/presentation/miniproject_presentation.pptx
+++ b/presentation/miniproject_presentation.pptx
@@ -11,8 +11,10 @@
     <p:sldId id="259" r:id="rId5"/>
     <p:sldId id="260" r:id="rId6"/>
     <p:sldId id="263" r:id="rId7"/>
-    <p:sldId id="261" r:id="rId8"/>
-    <p:sldId id="262" r:id="rId9"/>
+    <p:sldId id="264" r:id="rId8"/>
+    <p:sldId id="265" r:id="rId9"/>
+    <p:sldId id="261" r:id="rId10"/>
+    <p:sldId id="262" r:id="rId11"/>
   </p:sldIdLst>
   <p:sldSz cx="12192000" cy="6858000"/>
   <p:notesSz cx="6858000" cy="9144000"/>
@@ -3668,6 +3670,102 @@
 </p:sld>
 </file>
 
+<file path=ppt/slides/slide10.xml><?xml version="1.0" encoding="utf-8"?>
+<p:sld xmlns:a="http://schemas.openxmlformats.org/drawingml/2006/main" xmlns:r="http://schemas.openxmlformats.org/officeDocument/2006/relationships" xmlns:p="http://schemas.openxmlformats.org/presentationml/2006/main">
+  <p:cSld>
+    <p:spTree>
+      <p:nvGrpSpPr>
+        <p:cNvPr id="1" name=""/>
+        <p:cNvGrpSpPr/>
+        <p:nvPr/>
+      </p:nvGrpSpPr>
+      <p:grpSpPr>
+        <a:xfrm>
+          <a:off x="0" y="0"/>
+          <a:ext cx="0" cy="0"/>
+          <a:chOff x="0" y="0"/>
+          <a:chExt cx="0" cy="0"/>
+        </a:xfrm>
+      </p:grpSpPr>
+      <p:sp>
+        <p:nvSpPr>
+          <p:cNvPr id="2" name="Title 1">
+            <a:extLst>
+              <a:ext uri="{FF2B5EF4-FFF2-40B4-BE49-F238E27FC236}">
+                <a16:creationId xmlns:a16="http://schemas.microsoft.com/office/drawing/2014/main" id="{3907596B-4792-8F17-1652-319FEB91C8EF}"/>
+              </a:ext>
+            </a:extLst>
+          </p:cNvPr>
+          <p:cNvSpPr>
+            <a:spLocks noGrp="1"/>
+          </p:cNvSpPr>
+          <p:nvPr>
+            <p:ph type="title"/>
+          </p:nvPr>
+        </p:nvSpPr>
+        <p:spPr/>
+        <p:txBody>
+          <a:bodyPr/>
+          <a:lstStyle/>
+          <a:p>
+            <a:r>
+              <a:rPr lang="de-CH" dirty="0"/>
+              <a:t>Fulfillment </a:t>
+            </a:r>
+            <a:r>
+              <a:rPr lang="de-CH" dirty="0" err="1"/>
+              <a:t>of</a:t>
+            </a:r>
+            <a:r>
+              <a:rPr lang="de-CH" dirty="0"/>
+              <a:t> GRP </a:t>
+            </a:r>
+            <a:r>
+              <a:rPr lang="de-CH" dirty="0" err="1"/>
+              <a:t>principles</a:t>
+            </a:r>
+            <a:endParaRPr lang="en-CH" dirty="0"/>
+          </a:p>
+        </p:txBody>
+      </p:sp>
+      <p:sp>
+        <p:nvSpPr>
+          <p:cNvPr id="3" name="Content Placeholder 2">
+            <a:extLst>
+              <a:ext uri="{FF2B5EF4-FFF2-40B4-BE49-F238E27FC236}">
+                <a16:creationId xmlns:a16="http://schemas.microsoft.com/office/drawing/2014/main" id="{64A33FD8-6A2A-0342-4733-5268A07D6817}"/>
+              </a:ext>
+            </a:extLst>
+          </p:cNvPr>
+          <p:cNvSpPr>
+            <a:spLocks noGrp="1"/>
+          </p:cNvSpPr>
+          <p:nvPr>
+            <p:ph idx="1"/>
+          </p:nvPr>
+        </p:nvSpPr>
+        <p:spPr/>
+        <p:txBody>
+          <a:bodyPr/>
+          <a:lstStyle/>
+          <a:p>
+            <a:endParaRPr lang="en-CH"/>
+          </a:p>
+        </p:txBody>
+      </p:sp>
+    </p:spTree>
+    <p:extLst>
+      <p:ext uri="{BB962C8B-B14F-4D97-AF65-F5344CB8AC3E}">
+        <p14:creationId xmlns:p14="http://schemas.microsoft.com/office/powerpoint/2010/main" val="3978538866"/>
+      </p:ext>
+    </p:extLst>
+  </p:cSld>
+  <p:clrMapOvr>
+    <a:masterClrMapping/>
+  </p:clrMapOvr>
+</p:sld>
+</file>
+
 <file path=ppt/slides/slide2.xml><?xml version="1.0" encoding="utf-8"?>
 <p:sld xmlns:a="http://schemas.openxmlformats.org/drawingml/2006/main" xmlns:r="http://schemas.openxmlformats.org/officeDocument/2006/relationships" xmlns:p="http://schemas.openxmlformats.org/presentationml/2006/main">
   <p:cSld>
@@ -4436,10 +4534,133 @@
       </p:grpSpPr>
       <p:sp>
         <p:nvSpPr>
-          <p:cNvPr id="2" name="Title 1">
-            <a:extLst>
-              <a:ext uri="{FF2B5EF4-FFF2-40B4-BE49-F238E27FC236}">
-                <a16:creationId xmlns:a16="http://schemas.microsoft.com/office/drawing/2014/main" id="{FFE019AF-14F3-8BBB-6D3F-BC3ADFB90729}"/>
+          <p:cNvPr id="4" name="TextBox 3">
+            <a:extLst>
+              <a:ext uri="{FF2B5EF4-FFF2-40B4-BE49-F238E27FC236}">
+                <a16:creationId xmlns:a16="http://schemas.microsoft.com/office/drawing/2014/main" id="{6801204E-2620-B6AA-224D-3B07D4F82E8B}"/>
+              </a:ext>
+            </a:extLst>
+          </p:cNvPr>
+          <p:cNvSpPr txBox="1"/>
+          <p:nvPr/>
+        </p:nvSpPr>
+        <p:spPr>
+          <a:xfrm>
+            <a:off x="838200" y="3059668"/>
+            <a:ext cx="4337538" cy="2585323"/>
+          </a:xfrm>
+          <a:prstGeom prst="rect">
+            <a:avLst/>
+          </a:prstGeom>
+          <a:noFill/>
+        </p:spPr>
+        <p:txBody>
+          <a:bodyPr wrap="square" rtlCol="0">
+            <a:spAutoFit/>
+          </a:bodyPr>
+          <a:lstStyle/>
+          <a:p>
+            <a:r>
+              <a:rPr lang="en-GB" b="1" u="sng" dirty="0"/>
+              <a:t>Reproducibility!</a:t>
+            </a:r>
+            <a:endParaRPr lang="en-GB" u="sng" dirty="0"/>
+          </a:p>
+          <a:p>
+            <a:endParaRPr lang="en-GB" b="1" dirty="0"/>
+          </a:p>
+          <a:p>
+            <a:r>
+              <a:rPr lang="en-GB" dirty="0"/>
+              <a:t>There was no numerical or graphical exploration before model fitting…so we did it ourselves.</a:t>
+            </a:r>
+          </a:p>
+          <a:p>
+            <a:endParaRPr lang="en-GB" dirty="0"/>
+          </a:p>
+          <a:p>
+            <a:r>
+              <a:rPr lang="en-GB" dirty="0"/>
+              <a:t>Numerical Exploration </a:t>
+            </a:r>
+            <a:r>
+              <a:rPr lang="en-GB" b="1" dirty="0"/>
+              <a:t>suggested Non-normality </a:t>
+            </a:r>
+            <a:r>
+              <a:rPr lang="en-GB" dirty="0"/>
+              <a:t>of the response variable (Shapiro-wilk test).</a:t>
+            </a:r>
+            <a:endParaRPr lang="en-GB" b="1" dirty="0"/>
+          </a:p>
+        </p:txBody>
+      </p:sp>
+      <p:pic>
+        <p:nvPicPr>
+          <p:cNvPr id="6" name="Picture 5">
+            <a:extLst>
+              <a:ext uri="{FF2B5EF4-FFF2-40B4-BE49-F238E27FC236}">
+                <a16:creationId xmlns:a16="http://schemas.microsoft.com/office/drawing/2014/main" id="{358D9A13-85D8-0563-FBE0-DC1DA8E74367}"/>
+              </a:ext>
+            </a:extLst>
+          </p:cNvPr>
+          <p:cNvPicPr>
+            <a:picLocks noChangeAspect="1"/>
+          </p:cNvPicPr>
+          <p:nvPr/>
+        </p:nvPicPr>
+        <p:blipFill>
+          <a:blip r:embed="rId2"/>
+          <a:stretch>
+            <a:fillRect/>
+          </a:stretch>
+        </p:blipFill>
+        <p:spPr>
+          <a:xfrm>
+            <a:off x="5175738" y="2901583"/>
+            <a:ext cx="3270353" cy="3030286"/>
+          </a:xfrm>
+          <a:prstGeom prst="rect">
+            <a:avLst/>
+          </a:prstGeom>
+        </p:spPr>
+      </p:pic>
+      <p:pic>
+        <p:nvPicPr>
+          <p:cNvPr id="8" name="Picture 7">
+            <a:extLst>
+              <a:ext uri="{FF2B5EF4-FFF2-40B4-BE49-F238E27FC236}">
+                <a16:creationId xmlns:a16="http://schemas.microsoft.com/office/drawing/2014/main" id="{09D48FB5-F88D-6F47-9E3A-3A9A576541FA}"/>
+              </a:ext>
+            </a:extLst>
+          </p:cNvPr>
+          <p:cNvPicPr>
+            <a:picLocks noChangeAspect="1"/>
+          </p:cNvPicPr>
+          <p:nvPr/>
+        </p:nvPicPr>
+        <p:blipFill>
+          <a:blip r:embed="rId3"/>
+          <a:stretch>
+            <a:fillRect/>
+          </a:stretch>
+        </p:blipFill>
+        <p:spPr>
+          <a:xfrm>
+            <a:off x="8274468" y="3021853"/>
+            <a:ext cx="3270353" cy="3030286"/>
+          </a:xfrm>
+          <a:prstGeom prst="rect">
+            <a:avLst/>
+          </a:prstGeom>
+        </p:spPr>
+      </p:pic>
+      <p:sp>
+        <p:nvSpPr>
+          <p:cNvPr id="13" name="Title 1">
+            <a:extLst>
+              <a:ext uri="{FF2B5EF4-FFF2-40B4-BE49-F238E27FC236}">
+                <a16:creationId xmlns:a16="http://schemas.microsoft.com/office/drawing/2014/main" id="{F52E4CDB-23DA-16A8-2E04-05E17B805E9A}"/>
               </a:ext>
             </a:extLst>
           </p:cNvPr>
@@ -4450,89 +4671,61 @@
             <p:ph type="title"/>
           </p:nvPr>
         </p:nvSpPr>
-        <p:spPr/>
-        <p:txBody>
-          <a:bodyPr/>
-          <a:lstStyle/>
-          <a:p>
-            <a:r>
-              <a:rPr lang="de-CH" dirty="0"/>
-              <a:t>Soundness </a:t>
-            </a:r>
-            <a:r>
-              <a:rPr lang="de-CH" dirty="0" err="1"/>
-              <a:t>of</a:t>
-            </a:r>
-            <a:r>
-              <a:rPr lang="de-CH" dirty="0"/>
-              <a:t> </a:t>
-            </a:r>
-            <a:r>
-              <a:rPr lang="de-CH" dirty="0" err="1"/>
-              <a:t>Analyses</a:t>
-            </a:r>
-            <a:endParaRPr lang="en-CH" dirty="0"/>
-          </a:p>
-        </p:txBody>
-      </p:sp>
-      <p:sp>
-        <p:nvSpPr>
-          <p:cNvPr id="3" name="Content Placeholder 2">
-            <a:extLst>
-              <a:ext uri="{FF2B5EF4-FFF2-40B4-BE49-F238E27FC236}">
-                <a16:creationId xmlns:a16="http://schemas.microsoft.com/office/drawing/2014/main" id="{82D9D260-2761-E4EE-F884-D4F7769E696F}"/>
-              </a:ext>
-            </a:extLst>
-          </p:cNvPr>
-          <p:cNvSpPr>
-            <a:spLocks noGrp="1"/>
-          </p:cNvSpPr>
-          <p:nvPr>
-            <p:ph idx="1"/>
-          </p:nvPr>
-        </p:nvSpPr>
-        <p:spPr/>
-        <p:txBody>
-          <a:bodyPr/>
-          <a:lstStyle/>
-          <a:p>
-            <a:r>
-              <a:rPr lang="de-CH" dirty="0"/>
-              <a:t>Comments_on_analyses/timo.md</a:t>
-            </a:r>
-          </a:p>
-          <a:p>
-            <a:r>
-              <a:rPr lang="de-CH" dirty="0"/>
-              <a:t>Comments_on_analyses/mati.md</a:t>
-            </a:r>
-          </a:p>
-          <a:p>
-            <a:r>
-              <a:rPr lang="de-CH" dirty="0">
-                <a:sym typeface="Wingdings" panose="05000000000000000000" pitchFamily="2" charset="2"/>
+        <p:spPr>
+          <a:xfrm>
+            <a:off x="105508" y="142387"/>
+            <a:ext cx="11980984" cy="2108444"/>
+          </a:xfrm>
+        </p:spPr>
+        <p:txBody>
+          <a:bodyPr>
+            <a:normAutofit/>
+          </a:bodyPr>
+          <a:lstStyle/>
+          <a:p>
+            <a:pPr algn="ctr"/>
+            <a:r>
+              <a:rPr kumimoji="0" lang="en-GB" sz="4000" b="1" i="0" u="none" strike="noStrike" kern="1200" cap="none" spc="0" normalizeH="0" baseline="0" noProof="0" dirty="0">
+                <a:ln>
+                  <a:noFill/>
+                </a:ln>
+                <a:solidFill>
+                  <a:prstClr val="black"/>
+                </a:solidFill>
+                <a:effectLst/>
+                <a:uLnTx/>
+                <a:uFillTx/>
+                <a:latin typeface="Aptos Display" panose="02110004020202020204"/>
+                <a:ea typeface="+mj-ea"/>
+                <a:cs typeface="+mj-cs"/>
               </a:rPr>
-              <a:t> </a:t>
-            </a:r>
-            <a:r>
-              <a:rPr lang="de-CH" dirty="0" err="1"/>
-              <a:t>Comparison</a:t>
-            </a:r>
-            <a:endParaRPr lang="de-CH" dirty="0"/>
-          </a:p>
-          <a:p>
-            <a:r>
-              <a:rPr lang="de-CH" dirty="0" err="1"/>
-              <a:t>etc</a:t>
-            </a:r>
-            <a:endParaRPr lang="en-CH" dirty="0"/>
+              <a:t>Chromatic Camouflage Effectiveness </a:t>
+            </a:r>
+            <a:r>
+              <a:rPr kumimoji="0" lang="en-GB" sz="4000" b="0" i="0" u="none" strike="noStrike" kern="1200" cap="none" spc="0" normalizeH="0" baseline="0" noProof="0" dirty="0">
+                <a:ln>
+                  <a:noFill/>
+                </a:ln>
+                <a:solidFill>
+                  <a:prstClr val="black"/>
+                </a:solidFill>
+                <a:effectLst/>
+                <a:uLnTx/>
+                <a:uFillTx/>
+                <a:latin typeface="Aptos Display" panose="02110004020202020204"/>
+                <a:ea typeface="+mj-ea"/>
+                <a:cs typeface="+mj-cs"/>
+              </a:rPr>
+              <a:t>of Green and Red Chameleon Prawns Against Natural Seaweed Substrates as Perceived by Fish Predators</a:t>
+            </a:r>
+            <a:endParaRPr lang="en-GB" sz="4000" dirty="0"/>
           </a:p>
         </p:txBody>
       </p:sp>
     </p:spTree>
     <p:extLst>
       <p:ext uri="{BB962C8B-B14F-4D97-AF65-F5344CB8AC3E}">
-        <p14:creationId xmlns:p14="http://schemas.microsoft.com/office/powerpoint/2010/main" val="3738012847"/>
+        <p14:creationId xmlns:p14="http://schemas.microsoft.com/office/powerpoint/2010/main" val="3843164268"/>
       </p:ext>
     </p:extLst>
   </p:cSld>
@@ -4564,7 +4757,7 @@
           <p:cNvPr id="2" name="Title 1">
             <a:extLst>
               <a:ext uri="{FF2B5EF4-FFF2-40B4-BE49-F238E27FC236}">
-                <a16:creationId xmlns:a16="http://schemas.microsoft.com/office/drawing/2014/main" id="{3907596B-4792-8F17-1652-319FEB91C8EF}"/>
+                <a16:creationId xmlns:a16="http://schemas.microsoft.com/office/drawing/2014/main" id="{2FA47105-BE2D-4B69-A517-833453C9020F}"/>
               </a:ext>
             </a:extLst>
           </p:cNvPr>
@@ -4575,60 +4768,423 @@
             <p:ph type="title"/>
           </p:nvPr>
         </p:nvSpPr>
-        <p:spPr/>
-        <p:txBody>
-          <a:bodyPr/>
-          <a:lstStyle/>
-          <a:p>
-            <a:r>
-              <a:rPr lang="de-CH" dirty="0"/>
-              <a:t>Fulfillment </a:t>
-            </a:r>
-            <a:r>
-              <a:rPr lang="de-CH" dirty="0" err="1"/>
-              <a:t>of</a:t>
-            </a:r>
-            <a:r>
-              <a:rPr lang="de-CH" dirty="0"/>
-              <a:t> GRP </a:t>
-            </a:r>
-            <a:r>
-              <a:rPr lang="de-CH" dirty="0" err="1"/>
-              <a:t>principles</a:t>
-            </a:r>
-            <a:endParaRPr lang="en-CH" dirty="0"/>
-          </a:p>
-        </p:txBody>
-      </p:sp>
-      <p:sp>
-        <p:nvSpPr>
-          <p:cNvPr id="3" name="Content Placeholder 2">
-            <a:extLst>
-              <a:ext uri="{FF2B5EF4-FFF2-40B4-BE49-F238E27FC236}">
-                <a16:creationId xmlns:a16="http://schemas.microsoft.com/office/drawing/2014/main" id="{64A33FD8-6A2A-0342-4733-5268A07D6817}"/>
-              </a:ext>
-            </a:extLst>
-          </p:cNvPr>
-          <p:cNvSpPr>
-            <a:spLocks noGrp="1"/>
-          </p:cNvSpPr>
-          <p:nvPr>
-            <p:ph idx="1"/>
-          </p:nvPr>
-        </p:nvSpPr>
-        <p:spPr/>
-        <p:txBody>
-          <a:bodyPr/>
-          <a:lstStyle/>
-          <a:p>
-            <a:endParaRPr lang="en-CH"/>
-          </a:p>
-        </p:txBody>
-      </p:sp>
+        <p:spPr>
+          <a:xfrm>
+            <a:off x="105508" y="142387"/>
+            <a:ext cx="11980984" cy="2108444"/>
+          </a:xfrm>
+        </p:spPr>
+        <p:txBody>
+          <a:bodyPr>
+            <a:normAutofit/>
+          </a:bodyPr>
+          <a:lstStyle/>
+          <a:p>
+            <a:pPr algn="ctr"/>
+            <a:r>
+              <a:rPr kumimoji="0" lang="en-GB" sz="4000" b="1" i="0" u="none" strike="noStrike" kern="1200" cap="none" spc="0" normalizeH="0" baseline="0" noProof="0" dirty="0">
+                <a:ln>
+                  <a:noFill/>
+                </a:ln>
+                <a:solidFill>
+                  <a:prstClr val="black"/>
+                </a:solidFill>
+                <a:effectLst/>
+                <a:uLnTx/>
+                <a:uFillTx/>
+                <a:latin typeface="Aptos Display" panose="02110004020202020204"/>
+                <a:ea typeface="+mj-ea"/>
+                <a:cs typeface="+mj-cs"/>
+              </a:rPr>
+              <a:t>Chromatic Camouflage Effectiveness </a:t>
+            </a:r>
+            <a:r>
+              <a:rPr kumimoji="0" lang="en-GB" sz="4000" b="0" i="0" u="none" strike="noStrike" kern="1200" cap="none" spc="0" normalizeH="0" baseline="0" noProof="0" dirty="0">
+                <a:ln>
+                  <a:noFill/>
+                </a:ln>
+                <a:solidFill>
+                  <a:prstClr val="black"/>
+                </a:solidFill>
+                <a:effectLst/>
+                <a:uLnTx/>
+                <a:uFillTx/>
+                <a:latin typeface="Aptos Display" panose="02110004020202020204"/>
+                <a:ea typeface="+mj-ea"/>
+                <a:cs typeface="+mj-cs"/>
+              </a:rPr>
+              <a:t>of Green and Red Chameleon Prawns Against Natural Seaweed Substrates as Perceived by Fish Predators</a:t>
+            </a:r>
+            <a:endParaRPr lang="en-GB" sz="4000" dirty="0"/>
+          </a:p>
+        </p:txBody>
+      </p:sp>
+      <p:pic>
+        <p:nvPicPr>
+          <p:cNvPr id="7" name="Picture 6">
+            <a:extLst>
+              <a:ext uri="{FF2B5EF4-FFF2-40B4-BE49-F238E27FC236}">
+                <a16:creationId xmlns:a16="http://schemas.microsoft.com/office/drawing/2014/main" id="{223EA74C-97C6-8386-BACF-00667E0174A5}"/>
+              </a:ext>
+            </a:extLst>
+          </p:cNvPr>
+          <p:cNvPicPr>
+            <a:picLocks noChangeAspect="1"/>
+          </p:cNvPicPr>
+          <p:nvPr/>
+        </p:nvPicPr>
+        <p:blipFill>
+          <a:blip r:embed="rId2"/>
+          <a:stretch>
+            <a:fillRect/>
+          </a:stretch>
+        </p:blipFill>
+        <p:spPr>
+          <a:xfrm>
+            <a:off x="6480312" y="2250831"/>
+            <a:ext cx="4684622" cy="4340738"/>
+          </a:xfrm>
+          <a:prstGeom prst="rect">
+            <a:avLst/>
+          </a:prstGeom>
+        </p:spPr>
+      </p:pic>
+      <p:sp>
+        <p:nvSpPr>
+          <p:cNvPr id="9" name="TextBox 8">
+            <a:extLst>
+              <a:ext uri="{FF2B5EF4-FFF2-40B4-BE49-F238E27FC236}">
+                <a16:creationId xmlns:a16="http://schemas.microsoft.com/office/drawing/2014/main" id="{1D80D70C-A3AC-B39F-1FA6-3F30D4D95FB6}"/>
+              </a:ext>
+            </a:extLst>
+          </p:cNvPr>
+          <p:cNvSpPr txBox="1"/>
+          <p:nvPr/>
+        </p:nvSpPr>
+        <p:spPr>
+          <a:xfrm>
+            <a:off x="278296" y="2385043"/>
+            <a:ext cx="6202016" cy="923330"/>
+          </a:xfrm>
+          <a:prstGeom prst="rect">
+            <a:avLst/>
+          </a:prstGeom>
+          <a:noFill/>
+        </p:spPr>
+        <p:txBody>
+          <a:bodyPr wrap="square">
+            <a:spAutoFit/>
+          </a:bodyPr>
+          <a:lstStyle/>
+          <a:p>
+            <a:r>
+              <a:rPr lang="en-GB" b="1" i="1" dirty="0" err="1"/>
+              <a:t>jnd</a:t>
+            </a:r>
+            <a:r>
+              <a:rPr lang="en-GB" b="1" i="1" dirty="0"/>
+              <a:t> ~ morph * seaweed + (1 | ID)</a:t>
+            </a:r>
+            <a:endParaRPr lang="en-GB" dirty="0"/>
+          </a:p>
+          <a:p>
+            <a:endParaRPr lang="en-GB" b="1" i="1" dirty="0"/>
+          </a:p>
+          <a:p>
+            <a:r>
+              <a:rPr lang="en-GB" dirty="0"/>
+              <a:t>Are the model assumptions met, and did they check them…</a:t>
+            </a:r>
+          </a:p>
+        </p:txBody>
+      </p:sp>
+      <p:pic>
+        <p:nvPicPr>
+          <p:cNvPr id="11" name="Picture 10">
+            <a:extLst>
+              <a:ext uri="{FF2B5EF4-FFF2-40B4-BE49-F238E27FC236}">
+                <a16:creationId xmlns:a16="http://schemas.microsoft.com/office/drawing/2014/main" id="{4043E8CD-B076-711F-80AD-B0CDA075A0E4}"/>
+              </a:ext>
+            </a:extLst>
+          </p:cNvPr>
+          <p:cNvPicPr>
+            <a:picLocks noChangeAspect="1"/>
+          </p:cNvPicPr>
+          <p:nvPr/>
+        </p:nvPicPr>
+        <p:blipFill>
+          <a:blip r:embed="rId3">
+            <a:extLst>
+              <a:ext uri="{28A0092B-C50C-407E-A947-70E740481C1C}">
+                <a14:useLocalDpi xmlns:a14="http://schemas.microsoft.com/office/drawing/2010/main" val="0"/>
+              </a:ext>
+            </a:extLst>
+          </a:blip>
+          <a:stretch>
+            <a:fillRect/>
+          </a:stretch>
+        </p:blipFill>
+        <p:spPr>
+          <a:xfrm>
+            <a:off x="349527" y="3601569"/>
+            <a:ext cx="4152900" cy="622300"/>
+          </a:xfrm>
+          <a:prstGeom prst="rect">
+            <a:avLst/>
+          </a:prstGeom>
+        </p:spPr>
+      </p:pic>
+      <p:pic>
+        <p:nvPicPr>
+          <p:cNvPr id="5" name="Picture 4">
+            <a:extLst>
+              <a:ext uri="{FF2B5EF4-FFF2-40B4-BE49-F238E27FC236}">
+                <a16:creationId xmlns:a16="http://schemas.microsoft.com/office/drawing/2014/main" id="{C2E41040-1DD3-84D4-99E8-914E443FFD50}"/>
+              </a:ext>
+            </a:extLst>
+          </p:cNvPr>
+          <p:cNvPicPr>
+            <a:picLocks noChangeAspect="1"/>
+          </p:cNvPicPr>
+          <p:nvPr/>
+        </p:nvPicPr>
+        <p:blipFill>
+          <a:blip r:embed="rId4">
+            <a:extLst>
+              <a:ext uri="{28A0092B-C50C-407E-A947-70E740481C1C}">
+                <a14:useLocalDpi xmlns:a14="http://schemas.microsoft.com/office/drawing/2010/main" val="0"/>
+              </a:ext>
+            </a:extLst>
+          </a:blip>
+          <a:stretch>
+            <a:fillRect/>
+          </a:stretch>
+        </p:blipFill>
+        <p:spPr>
+          <a:xfrm>
+            <a:off x="1379733" y="3024023"/>
+            <a:ext cx="9785201" cy="1777391"/>
+          </a:xfrm>
+          <a:prstGeom prst="rect">
+            <a:avLst/>
+          </a:prstGeom>
+          <a:effectLst>
+            <a:glow rad="1905000">
+              <a:schemeClr val="bg1">
+                <a:lumMod val="85000"/>
+              </a:schemeClr>
+            </a:glow>
+            <a:outerShdw blurRad="50800" dist="50800" dir="5400000" sx="1000" sy="1000" algn="ctr" rotWithShape="0">
+              <a:srgbClr val="000000"/>
+            </a:outerShdw>
+            <a:softEdge rad="0"/>
+          </a:effectLst>
+        </p:spPr>
+      </p:pic>
     </p:spTree>
     <p:extLst>
       <p:ext uri="{BB962C8B-B14F-4D97-AF65-F5344CB8AC3E}">
-        <p14:creationId xmlns:p14="http://schemas.microsoft.com/office/powerpoint/2010/main" val="3978538866"/>
+        <p14:creationId xmlns:p14="http://schemas.microsoft.com/office/powerpoint/2010/main" val="4202063061"/>
+      </p:ext>
+    </p:extLst>
+  </p:cSld>
+  <p:clrMapOvr>
+    <a:masterClrMapping/>
+  </p:clrMapOvr>
+  <p:timing>
+    <p:tnLst>
+      <p:par>
+        <p:cTn id="1" dur="indefinite" restart="never" nodeType="tmRoot">
+          <p:childTnLst>
+            <p:seq concurrent="1" nextAc="seek">
+              <p:cTn id="2" dur="indefinite" nodeType="mainSeq">
+                <p:childTnLst>
+                  <p:par>
+                    <p:cTn id="3" fill="hold">
+                      <p:stCondLst>
+                        <p:cond delay="indefinite"/>
+                      </p:stCondLst>
+                      <p:childTnLst>
+                        <p:par>
+                          <p:cTn id="4" fill="hold">
+                            <p:stCondLst>
+                              <p:cond delay="0"/>
+                            </p:stCondLst>
+                            <p:childTnLst>
+                              <p:par>
+                                <p:cTn id="5" presetID="1" presetClass="entr" presetSubtype="0" fill="hold" nodeType="clickEffect">
+                                  <p:stCondLst>
+                                    <p:cond delay="0"/>
+                                  </p:stCondLst>
+                                  <p:childTnLst>
+                                    <p:set>
+                                      <p:cBhvr>
+                                        <p:cTn id="6" dur="1" fill="hold">
+                                          <p:stCondLst>
+                                            <p:cond delay="0"/>
+                                          </p:stCondLst>
+                                        </p:cTn>
+                                        <p:tgtEl>
+                                          <p:spTgt spid="5"/>
+                                        </p:tgtEl>
+                                        <p:attrNameLst>
+                                          <p:attrName>style.visibility</p:attrName>
+                                        </p:attrNameLst>
+                                      </p:cBhvr>
+                                      <p:to>
+                                        <p:strVal val="visible"/>
+                                      </p:to>
+                                    </p:set>
+                                  </p:childTnLst>
+                                </p:cTn>
+                              </p:par>
+                            </p:childTnLst>
+                          </p:cTn>
+                        </p:par>
+                      </p:childTnLst>
+                    </p:cTn>
+                  </p:par>
+                </p:childTnLst>
+              </p:cTn>
+              <p:prevCondLst>
+                <p:cond evt="onPrev" delay="0">
+                  <p:tgtEl>
+                    <p:sldTgt/>
+                  </p:tgtEl>
+                </p:cond>
+              </p:prevCondLst>
+              <p:nextCondLst>
+                <p:cond evt="onNext" delay="0">
+                  <p:tgtEl>
+                    <p:sldTgt/>
+                  </p:tgtEl>
+                </p:cond>
+              </p:nextCondLst>
+            </p:seq>
+          </p:childTnLst>
+        </p:cTn>
+      </p:par>
+    </p:tnLst>
+  </p:timing>
+</p:sld>
+</file>
+
+<file path=ppt/slides/slide9.xml><?xml version="1.0" encoding="utf-8"?>
+<p:sld xmlns:a="http://schemas.openxmlformats.org/drawingml/2006/main" xmlns:r="http://schemas.openxmlformats.org/officeDocument/2006/relationships" xmlns:p="http://schemas.openxmlformats.org/presentationml/2006/main">
+  <p:cSld>
+    <p:spTree>
+      <p:nvGrpSpPr>
+        <p:cNvPr id="1" name=""/>
+        <p:cNvGrpSpPr/>
+        <p:nvPr/>
+      </p:nvGrpSpPr>
+      <p:grpSpPr>
+        <a:xfrm>
+          <a:off x="0" y="0"/>
+          <a:ext cx="0" cy="0"/>
+          <a:chOff x="0" y="0"/>
+          <a:chExt cx="0" cy="0"/>
+        </a:xfrm>
+      </p:grpSpPr>
+      <p:sp>
+        <p:nvSpPr>
+          <p:cNvPr id="2" name="Title 1">
+            <a:extLst>
+              <a:ext uri="{FF2B5EF4-FFF2-40B4-BE49-F238E27FC236}">
+                <a16:creationId xmlns:a16="http://schemas.microsoft.com/office/drawing/2014/main" id="{FFE019AF-14F3-8BBB-6D3F-BC3ADFB90729}"/>
+              </a:ext>
+            </a:extLst>
+          </p:cNvPr>
+          <p:cNvSpPr>
+            <a:spLocks noGrp="1"/>
+          </p:cNvSpPr>
+          <p:nvPr>
+            <p:ph type="title"/>
+          </p:nvPr>
+        </p:nvSpPr>
+        <p:spPr/>
+        <p:txBody>
+          <a:bodyPr/>
+          <a:lstStyle/>
+          <a:p>
+            <a:r>
+              <a:rPr lang="de-CH" dirty="0"/>
+              <a:t>Soundness </a:t>
+            </a:r>
+            <a:r>
+              <a:rPr lang="de-CH" dirty="0" err="1"/>
+              <a:t>of</a:t>
+            </a:r>
+            <a:r>
+              <a:rPr lang="de-CH" dirty="0"/>
+              <a:t> </a:t>
+            </a:r>
+            <a:r>
+              <a:rPr lang="de-CH" dirty="0" err="1"/>
+              <a:t>Analyses</a:t>
+            </a:r>
+            <a:endParaRPr lang="en-CH" dirty="0"/>
+          </a:p>
+        </p:txBody>
+      </p:sp>
+      <p:sp>
+        <p:nvSpPr>
+          <p:cNvPr id="3" name="Content Placeholder 2">
+            <a:extLst>
+              <a:ext uri="{FF2B5EF4-FFF2-40B4-BE49-F238E27FC236}">
+                <a16:creationId xmlns:a16="http://schemas.microsoft.com/office/drawing/2014/main" id="{82D9D260-2761-E4EE-F884-D4F7769E696F}"/>
+              </a:ext>
+            </a:extLst>
+          </p:cNvPr>
+          <p:cNvSpPr>
+            <a:spLocks noGrp="1"/>
+          </p:cNvSpPr>
+          <p:nvPr>
+            <p:ph idx="1"/>
+          </p:nvPr>
+        </p:nvSpPr>
+        <p:spPr/>
+        <p:txBody>
+          <a:bodyPr/>
+          <a:lstStyle/>
+          <a:p>
+            <a:r>
+              <a:rPr lang="de-CH" dirty="0"/>
+              <a:t>Comments_on_analyses/timo.md</a:t>
+            </a:r>
+          </a:p>
+          <a:p>
+            <a:r>
+              <a:rPr lang="de-CH" dirty="0"/>
+              <a:t>Comments_on_analyses/mati.md</a:t>
+            </a:r>
+          </a:p>
+          <a:p>
+            <a:r>
+              <a:rPr lang="de-CH" dirty="0">
+                <a:sym typeface="Wingdings" panose="05000000000000000000" pitchFamily="2" charset="2"/>
+              </a:rPr>
+              <a:t> </a:t>
+            </a:r>
+            <a:r>
+              <a:rPr lang="de-CH" dirty="0" err="1"/>
+              <a:t>Comparison</a:t>
+            </a:r>
+            <a:endParaRPr lang="de-CH" dirty="0"/>
+          </a:p>
+          <a:p>
+            <a:r>
+              <a:rPr lang="de-CH" dirty="0" err="1"/>
+              <a:t>etc</a:t>
+            </a:r>
+            <a:endParaRPr lang="en-CH" dirty="0"/>
+          </a:p>
+        </p:txBody>
+      </p:sp>
+    </p:spTree>
+    <p:extLst>
+      <p:ext uri="{BB962C8B-B14F-4D97-AF65-F5344CB8AC3E}">
+        <p14:creationId xmlns:p14="http://schemas.microsoft.com/office/powerpoint/2010/main" val="3738012847"/>
       </p:ext>
     </p:extLst>
   </p:cSld>

</xml_diff>